<commit_message>
Unit 7: the two performance views (human and organisational)
</commit_message>
<xml_diff>
--- a/Unit decks/Unit 07 - Establishing Performance Expectations.pptx
+++ b/Unit decks/Unit 07 - Establishing Performance Expectations.pptx
@@ -26,7 +26,6 @@
     <p:sldId id="269" r:id="rId17"/>
     <p:sldId id="278" r:id="rId18"/>
     <p:sldId id="270" r:id="rId19"/>
-    <p:sldId id="271" r:id="rId20"/>
     <p:sldId id="280" r:id="rId21"/>
     <p:sldId id="273" r:id="rId22"/>
     <p:sldId id="274" r:id="rId23"/>
@@ -305,28 +304,46 @@
           <a:lstStyle/>
           <a:p>
             <a:r>
-              <a:rPr lang="en-US" dirty="0"/>
-              <a:t>UNIT 7 · ESTABLISHING PERFORMANCE EXPECTATIONS
-Module 3 · Influence · Unit 7
-Unit intent (Facilitator Guide):
-Unit 7 addresses the single most common reason strategy fails at the human level: expectations are communicated but never truly established. </a:t>
-            </a:r>
-          </a:p>
-          <a:p>
-            <a:r>
-              <a:rPr lang="en-US" dirty="0"/>
+              <a:t>UNIT 7 · ESTABLISHING PERFORMANCE EXPECTATIONS</a:t>
+            </a:r>
+          </a:p>
+          <a:p>
+            <a:r>
+              <a:t>Module 3 · Influence · Unit 7</a:t>
+            </a:r>
+          </a:p>
+          <a:p/>
+          <a:p>
+            <a:r>
+              <a:t>Unit intent (Facilitator Guide):</a:t>
+            </a:r>
+          </a:p>
+          <a:p>
+            <a:r>
+              <a:t>Unit 7 addresses the single most common reason strategy fails at the human level: expectations are communicated but never truly established. </a:t>
+            </a:r>
+          </a:p>
+          <a:p>
+            <a:r>
               <a:t>The distinction is subtle in language and profound in execution impact. </a:t>
             </a:r>
           </a:p>
           <a:p>
             <a:r>
-              <a:rPr lang="en-US" dirty="0"/>
               <a:t>The unit moves leaders from announcing targets to securing genuine ownership. This unit equips leaders to close the gap between a well-designed performance management system and genuine human commitment to deliver it.</a:t>
             </a:r>
           </a:p>
           <a:p>
-            <a:endParaRPr lang="en-US" dirty="0"/>
-          </a:p>
+            <a:r>
+              <a:t>Building on the S2R® Contribution Map™ and FACES developed in Unit 6, this unit establishes clear, realistic and mutually owned performance expectations. Every expectation is connected to an enterprise result, a human contribution and the organisational conditions required for delivery.</a:t>
+            </a:r>
+          </a:p>
+          <a:p>
+            <a:r>
+              <a:t>It builds on the S2R® Contribution Map™ and FACES of Unit 6. The expectation conversation covers both performance views: the human commitments people make, and the ESRG enabling conditions the organisation provides.</a:t>
+            </a:r>
+          </a:p>
+          <a:p/>
         </p:txBody>
       </p:sp>
       <p:sp>
@@ -753,38 +770,46 @@
           <a:lstStyle/>
           <a:p>
             <a:r>
-              <a:rPr lang="en-US" dirty="0"/>
-              <a:t>SECTION 2 · INTELLIGENCE — WHY
-Why Establishing Expectations Determines Execution Outcomes
-Understanding the behavioural mechanisms through which expectation alignment drives ownership, reduces ambiguity, surfaces constraints, and transforms accountability from formal obligation to personal commitment.
-Section learning outcomes:
-1. Explain how establishing expectations builds ownership and mutual accountability.
-2. Recognise how engagement and accountability degrade when expectations are only communicated.
-</a:t>
-            </a:r>
-            <a:endParaRPr dirty="0"/>
-          </a:p>
-          <a:p>
-            <a:r>
-              <a:rPr dirty="0"/>
+              <a:t>SECTION 2 · INTELLIGENCE — WHY</a:t>
+            </a:r>
+          </a:p>
+          <a:p>
+            <a:r>
+              <a:t>Why Establishing Expectations Determines Execution Outcomes</a:t>
+            </a:r>
+          </a:p>
+          <a:p>
+            <a:r>
+              <a:t>Understanding the behavioural mechanisms through which expectation alignment drives ownership, reduces ambiguity, surfaces constraints, and transforms accountability from formal obligation to personal commitment.</a:t>
+            </a:r>
+          </a:p>
+          <a:p/>
+          <a:p>
+            <a:r>
+              <a:t>Section learning outcomes:</a:t>
+            </a:r>
+          </a:p>
+          <a:p>
+            <a:r>
+              <a:t>1. Explain how expectation alignment affects commitment and execution.</a:t>
+            </a:r>
+          </a:p>
+          <a:p>
+            <a:r>
+              <a:t>2. Diagnose the performance consequences of unclear human and ESRG expectations.</a:t>
+            </a:r>
+          </a:p>
+          <a:p/>
+          <a:p/>
+          <a:p>
+            <a:r>
               <a:t>Why this section matters: Establishing performance expectations plays a decisive role in execution because strategy is ultimately delivered through human commitment. Plans, scorecards, and systems alone do not deliver it.</a:t>
             </a:r>
           </a:p>
-          <a:p>
-            <a:endParaRPr lang="en-ZA" dirty="0"/>
-          </a:p>
-          <a:p>
-            <a:r>
-              <a:rPr dirty="0"/>
-              <a:t>Organisations often invest significant effort in defining objectives, designing metrics, and building reporting structures. Execution outcomes are determined above all by whether the individuals responsible for delivery fully understand, accept, and </a:t>
-            </a:r>
-            <a:r>
-              <a:rPr dirty="0" err="1"/>
-              <a:t>internalise</a:t>
-            </a:r>
-            <a:r>
-              <a:rPr dirty="0"/>
-              <a:t> the expectations attached to their role. The technical design of the performance system is a lesser determinant.</a:t>
+          <a:p/>
+          <a:p>
+            <a:r>
+              <a:t>Organisations often invest significant effort in defining objectives, designing metrics, and building reporting structures. Execution outcomes are determined above all by whether the individuals responsible for delivery fully understand, accept, and internalise the expectations attached to their role. The technical design of the performance system is a lesser determinant.</a:t>
             </a:r>
           </a:p>
         </p:txBody>
@@ -870,56 +895,63 @@
           <a:lstStyle/>
           <a:p>
             <a:r>
-              <a:rPr lang="en-US" dirty="0"/>
-              <a:t>2.1 — COMPLIANCE VS COMMITMENT: THE EXECUTION DYNAMIC (Ignition point)
-FACILITATOR GUIDANCE
-Invite leaders to locate their current team: “If you are honest — when your team hits an obstacle, what happens first? Do they solve it, or do they escalate it? The answer tells you whether you have compliance or commitment.” This is a signal about whether expectations were established.
-Content:
-Strategy is ultimately delivered through human commitment. The moment when expectations are clarified between leader and contributor is the moment a performance target transitions from organisational intention to personal responsibility. If that transition does not occur, execution becomes fragile regardless of how well the system has been designed.
-</a:t>
-            </a:r>
-          </a:p>
-          <a:p>
-            <a:r>
-              <a:rPr lang="en-US" dirty="0"/>
-              <a:t>
-</a:t>
-            </a:r>
-            <a:r>
-              <a:rPr lang="en-GB" dirty="0"/>
+              <a:t>2.1 — COMPLIANCE VS COMMITMENT: THE EXECUTION DYNAMIC (Ignition point)</a:t>
+            </a:r>
+          </a:p>
+          <a:p/>
+          <a:p>
+            <a:r>
+              <a:t>FACILITATOR GUIDANCE</a:t>
+            </a:r>
+          </a:p>
+          <a:p>
+            <a:r>
+              <a:t>Invite leaders to locate their current team: “If you are honest — when your team hits an obstacle, what happens first? Do they solve it, or do they escalate it? The answer tells you whether you have compliance or commitment.” This is a signal about whether expectations were established.</a:t>
+            </a:r>
+          </a:p>
+          <a:p/>
+          <a:p>
+            <a:r>
+              <a:t>Content:</a:t>
+            </a:r>
+          </a:p>
+          <a:p>
+            <a:r>
+              <a:t>Strategy is ultimately delivered through human commitment. The moment when expectations are clarified between leader and contributor is the moment a performance target transitions from organisational intention to personal responsibility. If that transition does not occur, execution becomes fragile regardless of how well the system has been designed.</a:t>
+            </a:r>
+          </a:p>
+          <a:p>
+            <a:r>
+              <a:t>A compliance response may emerge when people are held accountable for results while essential organisational conditions remain outside their control. Commitment strengthens when leaders visibly fulfil their side of the performance agreement: decisions, systems, resources, governance and working environment.</a:t>
+            </a:r>
+          </a:p>
+          <a:p/>
+          <a:p/>
+          <a:p>
+            <a:r>
               <a:t>From instruction to ownership: When expectations are merely communicated, people typically interpret them as instructions, and this produces a compliance-based execution dynamic. </a:t>
             </a:r>
           </a:p>
-          <a:p>
-            <a:endParaRPr lang="en-GB" dirty="0"/>
-          </a:p>
-          <a:p>
-            <a:r>
-              <a:rPr lang="en-GB" dirty="0"/>
+          <a:p/>
+          <a:p>
+            <a:r>
               <a:t>In compliance environments, individuals tend to wait for direction before acting, escalate problems upward and leave them unresolved, focus on reporting progress ahead of accelerating outcomes, and remain cautious when unexpected obstacles arise.</a:t>
             </a:r>
           </a:p>
-          <a:p>
-            <a:endParaRPr lang="en-GB" dirty="0"/>
-          </a:p>
-          <a:p>
-            <a:r>
-              <a:rPr dirty="0"/>
+          <a:p/>
+          <a:p>
+            <a:r>
               <a:t>When expectations are properly established through structured dialogue, a different dynamic emerges. This shift fundamentally changes behaviour. Ownership encourages individuals to invest greater effort in solving obstacles. The expectation stops being a target imposed by the system and becomes something the individual is personally accountable for delivering.</a:t>
             </a:r>
           </a:p>
-          <a:p>
-            <a:endParaRPr dirty="0"/>
-          </a:p>
-          <a:p>
-            <a:r>
-              <a:rPr dirty="0"/>
+          <a:p/>
+          <a:p>
+            <a:r>
               <a:t>Build commitments that hold without the pressure.</a:t>
             </a:r>
           </a:p>
           <a:p>
             <a:r>
-              <a:rPr dirty="0"/>
               <a:t>Teams often say yes to a new way of working while quietly keeping the old habits underneath. People who keep both systems running have committed to neither. Bring the hidden habits into the open.</a:t>
             </a:r>
           </a:p>
@@ -1354,184 +1386,145 @@
           <a:lstStyle/>
           <a:p>
             <a:r>
-              <a:rPr lang="en-US" dirty="0"/>
-              <a:t>2.3 — ENGAGEMENT &amp; ACCOUNTABILITY: THE TWO CASUALTIES (What breaks down when expectations are only set)
-FACILITATOR GUIDANCE
-The paradox in the Accountability card is often a moment of recognition for leaders. Name it explicitly: “Have you ever been in a review where everyone has a reason, and no one has an answer? That is diluted accountability in action. It happened because ownership was never established.”
-</a:t>
-            </a:r>
-            <a:r>
-              <a:rPr lang="en-US" b="1" dirty="0"/>
+              <a:t>2.3 — ENGAGEMENT &amp; ACCOUNTABILITY: THE TWO CASUALTIES (What breaks down when expectations are only set)</a:t>
+            </a:r>
+          </a:p>
+          <a:p/>
+          <a:p>
+            <a:r>
+              <a:t>FACILITATOR GUIDANCE</a:t>
+            </a:r>
+          </a:p>
+          <a:p>
+            <a:r>
+              <a:t>The paradox in the Accountability card is often a moment of recognition for leaders. Name it explicitly: “Have you ever been in a review where everyone has a reason, and no one has an answer? That is diluted accountability in action. It happened because ownership was never established.”</a:t>
+            </a:r>
+          </a:p>
+          <a:p/>
+          <a:p>
+            <a:r>
               <a:t>Content:</a:t>
             </a:r>
-            <a:r>
-              <a:rPr lang="en-US" dirty="0"/>
-              <a:t>
-When expectations are set without being established, two organisational conditions degrade in a predictable sequence.
-</a:t>
-            </a:r>
-          </a:p>
-          <a:p>
-            <a:r>
-              <a:rPr lang="en-US" b="1" dirty="0"/>
+          </a:p>
+          <a:p>
+            <a:r>
+              <a:t>When expectations are set without being established, two organisational conditions degrade in a predictable sequence.</a:t>
+            </a:r>
+          </a:p>
+          <a:p>
+            <a:r>
+              <a:t>Two failures often appear together: contributors disengage because promises of support are not honoured, and accountability becomes defensive because responsibility for the result is disconnected from authority over its enabling conditions. The expectation record must therefore distinguish the delivery owner from the ESRG resolution owner.</a:t>
+            </a:r>
+          </a:p>
+          <a:p/>
+          <a:p>
+            <a:r>
               <a:t>First Casualty</a:t>
             </a:r>
-            <a:r>
-              <a:rPr lang="en-US" dirty="0"/>
-              <a:t>
-</a:t>
-            </a:r>
-            <a:r>
-              <a:rPr lang="en-GB" b="1" dirty="0"/>
+          </a:p>
+          <a:p>
+            <a:r>
               <a:t>Engagement, the first casualty</a:t>
             </a:r>
           </a:p>
           <a:p>
             <a:r>
-              <a:rPr lang="en-GB" dirty="0"/>
               <a:t>One of the earliest behavioural consequences of setting expectations without properly establishing them appears in the level of engagement across the organisation. People recognise the expectation as part of their work environment, yet they may not experience it as something they have consciously committed to achieving. </a:t>
             </a:r>
           </a:p>
           <a:p>
             <a:r>
-              <a:rPr lang="en-GB" dirty="0"/>
               <a:t>As a result, engagement begins to weaken in subtle but observable ways.</a:t>
             </a:r>
           </a:p>
           <a:p>
             <a:r>
-              <a:rPr lang="en-GB" dirty="0"/>
               <a:t>Individuals complete assigned tasks yet hesitate to go beyond their defined scope. Initiative declines because people do not feel authorised, or obligated, to intervene when obstacles arise outside their immediate area of responsibility. </a:t>
             </a:r>
           </a:p>
           <a:p>
             <a:r>
-              <a:rPr lang="en-GB" dirty="0"/>
               <a:t>Teams concentrate on completing assigned tasks and leave the broader organisational challenge unsolved. </a:t>
             </a:r>
           </a:p>
           <a:p>
             <a:r>
-              <a:rPr lang="en-GB" dirty="0"/>
               <a:t>Individuals behave as though they are implementing someone else’s expectation, with no sense of advancing a commitment they helped shape.</a:t>
             </a:r>
           </a:p>
           <a:p>
             <a:r>
-              <a:rPr lang="en-GB" dirty="0"/>
               <a:t>How dialogue reverses it: When expectations are established through dialogue, the dynamic shifts significantly.</a:t>
             </a:r>
           </a:p>
           <a:p>
             <a:r>
-              <a:rPr lang="en-GB" dirty="0"/>
               <a:t> Individuals participate in clarifying the conditions required for delivery, surfacing constraints, and confirming the feasibility of the outcome. </a:t>
             </a:r>
           </a:p>
           <a:p>
             <a:r>
-              <a:rPr lang="en-GB" dirty="0"/>
               <a:t>This process strengthens their connection to the expectation and increases their willingness to invest discretionary effort. </a:t>
             </a:r>
           </a:p>
           <a:p>
             <a:r>
-              <a:rPr lang="en-GB" dirty="0"/>
               <a:t>Engagement rises because individuals see the outcome as a shared commitment they have helped define and are motivated to deliver.</a:t>
             </a:r>
           </a:p>
-          <a:p>
-            <a:endParaRPr lang="en-US" dirty="0"/>
-          </a:p>
-          <a:p>
-            <a:endParaRPr dirty="0"/>
-          </a:p>
-          <a:p>
-            <a:endParaRPr dirty="0"/>
-          </a:p>
-          <a:p>
-            <a:r>
-              <a:rPr b="1" dirty="0"/>
+          <a:p/>
+          <a:p/>
+          <a:p/>
+          <a:p>
+            <a:r>
               <a:t>Accountability, the critical long-term impact </a:t>
             </a:r>
-            <a:endParaRPr lang="en-ZA" b="1" dirty="0"/>
-          </a:p>
-          <a:p>
-            <a:r>
-              <a:rPr dirty="0"/>
+          </a:p>
+          <a:p>
+            <a:r>
               <a:t>Accountability functions effectively when individuals clearly understand both what outcome they are responsible for and the conditions under which that outcome must be delivered. When expectations are set without thorough alignment, this clarity is often incomplete. </a:t>
             </a:r>
-            <a:endParaRPr lang="en-ZA" dirty="0"/>
-          </a:p>
-          <a:p>
-            <a:r>
-              <a:rPr dirty="0"/>
+          </a:p>
+          <a:p>
+            <a:r>
               <a:t>Individuals may feel responsible for carrying out their activities (executing tasks, completing projects, producing reports) and still not feel fully responsible for the final organisational result.</a:t>
             </a:r>
           </a:p>
           <a:p>
             <a:r>
-              <a:rPr dirty="0"/>
-              <a:t>Over time, this ambiguity produces several familiar organisational </a:t>
-            </a:r>
-            <a:r>
-              <a:rPr dirty="0" err="1"/>
-              <a:t>behaviours</a:t>
-            </a:r>
-            <a:r>
-              <a:rPr dirty="0"/>
-              <a:t>. Performance discussions increasingly revolve around explanations, conversations focus on constraints ahead of solutions, and it becomes difficult to identify who ultimately owns the result. </a:t>
-            </a:r>
-            <a:endParaRPr lang="en-ZA" dirty="0"/>
-          </a:p>
-          <a:p>
-            <a:r>
-              <a:rPr dirty="0"/>
+              <a:t>Over time, this ambiguity produces several familiar organisational behaviours. Performance discussions increasingly revolve around explanations, conversations focus on constraints ahead of solutions, and it becomes difficult to identify who ultimately owns the result. </a:t>
+            </a:r>
+          </a:p>
+          <a:p>
+            <a:r>
               <a:t>In such environments leaders often observe a persistent paradox. Activity levels are high, and effort and capability are not necessarily the issue: the organisation has assigned expectations without fully securing ownership of the outcome.</a:t>
             </a:r>
           </a:p>
           <a:p>
             <a:r>
-              <a:rPr dirty="0"/>
               <a:t>How establishing restores it: When expectations are properly established, accountability becomes clearer and more effective. </a:t>
             </a:r>
-            <a:endParaRPr lang="en-ZA" dirty="0"/>
-          </a:p>
-          <a:p>
-            <a:r>
-              <a:rPr dirty="0"/>
+          </a:p>
+          <a:p>
+            <a:r>
               <a:t>Individuals understand the results they are responsible for, the dependencies involved in delivering those results, and the support structures available to them. This clarity enables teams to address challenges earlier and to take ownership of resolving obstacles. </a:t>
             </a:r>
-            <a:endParaRPr lang="en-ZA" dirty="0"/>
-          </a:p>
-          <a:p>
-            <a:r>
-              <a:rPr dirty="0"/>
+          </a:p>
+          <a:p>
+            <a:r>
               <a:t>Establishing expectations does more than clarify performance targets. It creates the behavioural foundation for sustained accountability, ensuring that individuals and teams take responsibility for the work they perform and for the results that work is intended to produce.</a:t>
             </a:r>
           </a:p>
-          <a:p>
-            <a:endParaRPr dirty="0"/>
-          </a:p>
-          <a:p>
-            <a:endParaRPr dirty="0"/>
-          </a:p>
-          <a:p>
-            <a:r>
-              <a:rPr dirty="0"/>
-              <a:t>Engagement becomes transactional: Many teams run on minimum compliance: do what is required, claim the credit, defend the boundary</a:t>
-            </a:r>
-            <a:r>
-              <a:rPr lang="en-GB" dirty="0"/>
-              <a:t>. </a:t>
-            </a:r>
-          </a:p>
-          <a:p>
-            <a:endParaRPr lang="en-GB" dirty="0"/>
-          </a:p>
-          <a:p>
-            <a:r>
-              <a:rPr dirty="0"/>
+          <a:p/>
+          <a:p/>
+          <a:p>
+            <a:r>
+              <a:t>Engagement becomes transactional: Many teams run on minimum compliance: do what is required, claim the credit, defend the boundary. </a:t>
+            </a:r>
+          </a:p>
+          <a:p/>
+          <a:p>
+            <a:r>
               <a:t>Quiet non-participation: Indifference is the most underestimated risk to a strategic agenda, because quiet non-participation is invisible. Identify the people who have neither opposed nor engaged the initiative, ask each one directly whether they are in, and bring them in or redesign around them.</a:t>
             </a:r>
           </a:p>
@@ -1618,26 +1611,42 @@
           <a:lstStyle/>
           <a:p>
             <a:r>
-              <a:rPr lang="en-US" dirty="0"/>
-              <a:t>SECTION 3 · EXTRAPOLATING — WHERE
-Where Does the Expectations Gap Emerge?
-Examining how each executive function’s natural tendency creates patterns of setting expectations without establishing them — and where the gap most commonly breaks engagement and accountability at scale.
-Section learning outcomes:
-1. Identify where each executive function tends to set expectations without securing ownership.
-2. Recognise the contributors and dependencies each executive role relies on to deliver an agreed result.</a:t>
-            </a:r>
-          </a:p>
-          <a:p>
-            <a:endParaRPr lang="en-US" dirty="0"/>
-          </a:p>
+              <a:t>SECTION 3 · EXTRAPOLATING — WHERE</a:t>
+            </a:r>
+          </a:p>
+          <a:p>
+            <a:r>
+              <a:t>Where Does the Expectations Gap Emerge?</a:t>
+            </a:r>
+          </a:p>
+          <a:p>
+            <a:r>
+              <a:t>Examining how each executive function’s natural tendency creates patterns of setting expectations without establishing them — and where the gap most commonly breaks engagement and accountability at scale.</a:t>
+            </a:r>
+          </a:p>
+          <a:p/>
+          <a:p>
+            <a:r>
+              <a:t>Section learning outcomes:</a:t>
+            </a:r>
+          </a:p>
+          <a:p>
+            <a:r>
+              <a:t>1. Identify leadership tendencies that weaken expectation alignment.</a:t>
+            </a:r>
+          </a:p>
+          <a:p>
+            <a:r>
+              <a:t>2. Locate ownership gaps across contribution relationships and enabling conditions.</a:t>
+            </a:r>
+          </a:p>
+          <a:p/>
           <a:p>
             <a:r>
               <a:t>Source detail (S2R® manuscript):</a:t>
             </a:r>
           </a:p>
-          <a:p>
-            <a:endParaRPr/>
-          </a:p>
+          <a:p/>
           <a:p>
             <a:r>
               <a:t>Where the tendencies come from: Across the executive team, the expectation tendencies arise from functional expertise. Setting expectations within a function does not automatically establish delivery expectations across the enterprise system.</a:t>
@@ -1736,52 +1745,53 @@
           <a:lstStyle/>
           <a:p>
             <a:r>
-              <a:rPr lang="en-US" dirty="0"/>
-              <a:t>3.1 — THE COLLECTIVE INTELLIGENCE FOR EXECUTION DISCIPLINE: CXO EXPECTATION TENDENCIES &amp; GAPS (10 executive roles)
-What the ten tendencies have in common: Setting expectations ensures that people know what leadership wants. Establishing expectations ensures that the individuals understand the conditions required for success, accept ownership of the outcome, and are prepared to mobilise the system needed to achieve it.</a:t>
-            </a:r>
-            <a:r>
-              <a:rPr dirty="0"/>
-              <a:t/>
-            </a:r>
-            <a:r>
-              <a:rPr dirty="0" err="1"/>
-              <a:t/>
-            </a:r>
-            <a:r>
-              <a:rPr dirty="0"/>
-              <a:t/>
-            </a:r>
-          </a:p>
-          <a:p>
-            <a:r>
-              <a:rPr dirty="0"/>
+              <a:t>FACILITATOR GUIDANCE</a:t>
+            </a:r>
+          </a:p>
+          <a:p>
+            <a:r>
+              <a:t>For each role, examine the expectations it places on others and the ESRG commitments it must honour. Finance may control resources, operations may own systems and work design, HR may influence capability and environment, and executive leadership may own governance decisions. These are illustrative accountabilities; confirm actual ownership in the capstone organisation.</a:t>
+            </a:r>
+          </a:p>
+          <a:p>
+            <a:r>
+              <a:t>Ask: “Which expectation is this leader placing on another function, and what enabling promise is this leader making in return?” Capture unowned dependencies as alignment gaps.</a:t>
+            </a:r>
+          </a:p>
+          <a:p>
+            <a:r>
+              <a:t>Each role card gives the Upline, Downline and Crossline of the role’s likely Expectations Chain.</a:t>
+            </a:r>
+          </a:p>
+          <a:p/>
+          <a:p>
+            <a:r>
+              <a:t>3.1 — THE COLLECTIVE INTELLIGENCE FOR EXECUTION DISCIPLINE: CXO EXPECTATION TENDENCIES &amp; GAPS (10 executive roles)</a:t>
+            </a:r>
+          </a:p>
+          <a:p/>
+          <a:p>
+            <a:r>
+              <a:t>What the ten tendencies have in common: Setting expectations ensures that people know what leadership wants. Establishing expectations ensures that the individuals understand the conditions required for success, accept ownership of the outcome, and are prepared to mobilise the system needed to achieve it.</a:t>
+            </a:r>
+          </a:p>
+          <a:p>
+            <a:r>
               <a:t>When this step is overlooked, the organisation may appear aligned at the surface level while important behavioural conditions remain unresolved beneath it. Two of the most common consequences begin to emerge over time:</a:t>
             </a:r>
           </a:p>
           <a:p>
             <a:r>
-              <a:rPr dirty="0"/>
-              <a:t>- Engagement begins to weaken, as individuals carry out instructions without fully </a:t>
-            </a:r>
-            <a:r>
-              <a:rPr dirty="0" err="1"/>
-              <a:t>internalising</a:t>
-            </a:r>
-            <a:r>
-              <a:rPr dirty="0"/>
-              <a:t> the commitment required to deliver the result.</a:t>
-            </a:r>
-          </a:p>
-          <a:p>
-            <a:r>
-              <a:rPr dirty="0"/>
+              <a:t>- Engagement begins to weaken, as individuals carry out instructions without fully internalising the commitment required to deliver the result.</a:t>
+            </a:r>
+          </a:p>
+          <a:p>
+            <a:r>
               <a:t>- Accountability becomes diluted, as responsibility for outcomes becomes ambiguous across teams and functions.</a:t>
             </a:r>
           </a:p>
           <a:p>
             <a:r>
-              <a:rPr dirty="0"/>
               <a:t>Understanding how these dynamics develop helps explain why expectation alignment is such a decisive leadership practice in strategy execution. The absence of established expectations most visibly affects engagement and accountability, and these two behavioural shifts often determine whether organisational priorities translate into real results. Both are detailed in the notes of the two casualties slide (2.3).</a:t>
             </a:r>
           </a:p>
@@ -2084,42 +2094,54 @@
           <a:lstStyle/>
           <a:p>
             <a:r>
-              <a:rPr lang="en-US" b="1" dirty="0"/>
               <a:t>SECTION 4 · INTEGRATION — COLLECTIVE</a:t>
             </a:r>
-            <a:r>
-              <a:rPr lang="en-US" dirty="0"/>
-              <a:t>
-Cross-Leadership Expectation Architecture
-Designing a shared method for establishing expectations consistently across the organisation — connecting every expectation to the future, clarifying the chain, and securing ownership through the Alignment Dialogue.
-Section learning outcomes:
-1. Apply a consistent leadership practice for establishing expectations across the organisation.
-2. Coach individuals from partial alignment to genuine commitment.
-</a:t>
-            </a:r>
-            <a:r>
-              <a:rPr dirty="0"/>
+          </a:p>
+          <a:p>
+            <a:r>
+              <a:t>Cross-Leadership Expectation Architecture</a:t>
+            </a:r>
+          </a:p>
+          <a:p>
+            <a:r>
+              <a:t>Practising the Alignment Dialogue across leadership roles — testing the contribution each person will deliver and what the organisation must enable for it.</a:t>
+            </a:r>
+          </a:p>
+          <a:p/>
+          <a:p>
+            <a:r>
+              <a:t>Section learning outcomes:</a:t>
+            </a:r>
+          </a:p>
+          <a:p>
+            <a:r>
+              <a:t>1. Coach individuals from partial alignment to genuine commitment.</a:t>
+            </a:r>
+          </a:p>
+          <a:p>
+            <a:r>
+              <a:t>2. Demonstrate an alignment dialogue covering commitments and ESRG dependencies.</a:t>
+            </a:r>
+          </a:p>
+          <a:p/>
+          <a:p>
+            <a:r>
               <a:t>This section brings the leadership team together to define how expectations will be established consistently across the organisation.</a:t>
             </a:r>
           </a:p>
           <a:p>
             <a:r>
-              <a:rPr dirty="0"/>
               <a:t>In many organisations, expectations are communicated through different functional mechanisms: budgets, project plans, operational procedures, campaign targets, or performance reviews. While these tools provide clarity within each function, they often lack a shared method for establishing delivery expectations across the enterprise.</a:t>
             </a:r>
           </a:p>
-          <a:p>
-            <a:endParaRPr lang="en-ZA" dirty="0"/>
-          </a:p>
-          <a:p>
-            <a:r>
-              <a:rPr dirty="0"/>
+          <a:p/>
+          <a:p>
+            <a:r>
               <a:t>Without a common approach, expectations can be interpreted differently across teams. People may understand the priority, yet remain uncertain about how it connects to the organisation’s broader direction or who ultimately owns delivery.</a:t>
             </a:r>
           </a:p>
           <a:p>
             <a:r>
-              <a:rPr dirty="0"/>
               <a:t>The purpose of the Converging Zone is therefore to create a simple expectation architecture that everyone in the organisation can use. This architecture ensures that expectations are clearly understood, connected to the organisational future, and owned by the people responsible for delivering them.</a:t>
             </a:r>
           </a:p>
@@ -2143,237 +2165,6 @@
             <a:fld id="{F7021451-1387-4CA6-816F-3879F97B5CBC}" type="slidenum">
               <a:rPr lang="en-US"/>
               <a:t>18</a:t>
-            </a:fld>
-            <a:endParaRPr lang="en-US"/>
-          </a:p>
-        </p:txBody>
-      </p:sp>
-    </p:spTree>
-    <p:extLst>
-      <p:ext uri="{BB962C8B-B14F-4D97-AF65-F5344CB8AC3E}">
-        <p14:creationId xmlns:p14="http://schemas.microsoft.com/office/powerpoint/2010/main" val="1024086991"/>
-      </p:ext>
-    </p:extLst>
-  </p:cSld>
-  <p:clrMapOvr>
-    <a:masterClrMapping/>
-  </p:clrMapOvr>
-</p:notes>
-</file>
-
-<file path=ppt/notesSlides/notesSlide19.xml><?xml version="1.0" encoding="utf-8"?>
-<p:notes xmlns:a="http://schemas.openxmlformats.org/drawingml/2006/main" xmlns:r="http://schemas.openxmlformats.org/officeDocument/2006/relationships" xmlns:p="http://schemas.openxmlformats.org/presentationml/2006/main">
-  <p:cSld>
-    <p:spTree>
-      <p:nvGrpSpPr>
-        <p:cNvPr id="1" name=""/>
-        <p:cNvGrpSpPr/>
-        <p:nvPr/>
-      </p:nvGrpSpPr>
-      <p:grpSpPr>
-        <a:xfrm>
-          <a:off x="0" y="0"/>
-          <a:ext cx="0" cy="0"/>
-          <a:chOff x="0" y="0"/>
-          <a:chExt cx="0" cy="0"/>
-        </a:xfrm>
-      </p:grpSpPr>
-      <p:sp>
-        <p:nvSpPr>
-          <p:cNvPr id="2" name="Slide Image Placeholder 1"/>
-          <p:cNvSpPr>
-            <a:spLocks noGrp="1" noRot="1" noChangeAspect="1"/>
-          </p:cNvSpPr>
-          <p:nvPr>
-            <p:ph type="sldImg"/>
-          </p:nvPr>
-        </p:nvSpPr>
-        <p:spPr/>
-      </p:sp>
-      <p:sp>
-        <p:nvSpPr>
-          <p:cNvPr id="3" name="Notes Placeholder 2"/>
-          <p:cNvSpPr>
-            <a:spLocks noGrp="1"/>
-          </p:cNvSpPr>
-          <p:nvPr>
-            <p:ph type="body" idx="1"/>
-          </p:nvPr>
-        </p:nvSpPr>
-        <p:spPr/>
-        <p:txBody>
-          <a:bodyPr/>
-          <a:lstStyle/>
-          <a:p>
-            <a:r>
-              <a:rPr lang="en-US" dirty="0"/>
-              <a:t>4.1 — THE FOUR-STEP EXPECTATION ARCHITECTURE (A shared leadership practice)
-The groups work to complete the expectations architecture.</a:t>
-            </a:r>
-          </a:p>
-          <a:p>
-            <a:r>
-              <a:rPr lang="en-US" dirty="0"/>
-              <a:t>
-The Expectation Architecture provides a simple, consistent method that every leader in the organisation can use — from executives to team leaders to individual contributors — to move expectations from communication into genuine ownership.
-1. Start With the Future
-2. Clarify the Delivery Expectation
-3. Identify the Expectations Chain
-4. Confirm Ownership
-</a:t>
-            </a:r>
-          </a:p>
-          <a:p>
-            <a:r>
-              <a:rPr lang="en-US" dirty="0"/>
-              <a:t>Begin by connecting the expectation to the organisation’s Success in Practice (SiP) — the future state the organisation is pursuing.</a:t>
-            </a:r>
-          </a:p>
-          <a:p>
-            <a:r>
-              <a:rPr lang="en-US" dirty="0"/>
-              <a:t>
-The objective is to help the individual understand why the expectation matters. This anchors the expectation in organisational purpose.
-</a:t>
-            </a:r>
-          </a:p>
-          <a:p>
-            <a:r>
-              <a:rPr lang="en-US" dirty="0"/>
-              <a:t>Example leader framing:</a:t>
-            </a:r>
-          </a:p>
-          <a:p>
-            <a:r>
-              <a:rPr lang="en-GB" dirty="0"/>
-              <a:t>Starting with the future: At this stage the leader explains how the expectation contributes to the broader outcome the organisation is pursuing. </a:t>
-            </a:r>
-            <a:r>
-              <a:rPr lang="en-US" dirty="0"/>
-              <a:t>
-“The outcome we need is a reduction in resolution time from 48 hours to 12 hours by the end of Q3 2026. </a:t>
-            </a:r>
-          </a:p>
-          <a:p>
-            <a:r>
-              <a:rPr lang="en-US" dirty="0"/>
-              <a:t>That is the result we are holding ourselves to: the outcome we are accountable for.”
-</a:t>
-            </a:r>
-          </a:p>
-          <a:p>
-            <a:pPr marL="0" marR="0" lvl="0" indent="0" algn="l" defTabSz="914400" rtl="0" eaLnBrk="1" fontAlgn="auto" latinLnBrk="0" hangingPunct="1">
-              <a:lnSpc>
-                <a:spcPct val="100000"/>
-              </a:lnSpc>
-              <a:spcBef>
-                <a:spcPts val="0"/>
-              </a:spcBef>
-              <a:spcAft>
-                <a:spcPts val="0"/>
-              </a:spcAft>
-              <a:buClrTx/>
-              <a:buSzTx/>
-              <a:buFontTx/>
-              <a:buNone/>
-              <a:tabLst/>
-              <a:defRPr/>
-            </a:pPr>
-            <a:r>
-              <a:rPr lang="en-US" dirty="0"/>
-              <a:t>Clarity is tested by asking the individual to describe what success looks like in their own words. </a:t>
-            </a:r>
-            <a:r>
-              <a:rPr lang="en-GB" dirty="0"/>
-              <a:t>This step removes ambiguity and ensures that both parties share a clear picture of the result to be delivered.</a:t>
-            </a:r>
-          </a:p>
-          <a:p>
-            <a:r>
-              <a:rPr lang="en-US" dirty="0"/>
-              <a:t>If the description differs from the leader’s, the expectation requires further clarification before proceeding.
-With the outcome clear, identify who else must contribute for the result to be achieved.
-</a:t>
-            </a:r>
-          </a:p>
-          <a:p>
-            <a:r>
-              <a:rPr lang="en-US" dirty="0"/>
-              <a:t>Most organisational outcomes depend on multiple contributors. By mapping the Expectations Chain early, the leader ensures that dependencies are visible before execution begins.
-The conversation explores:
-Which teams or individuals will need to collaborate on this outcome?
-Whose decisions or resources directly influence the delivery of the result?
-Where might coordination be required across functions?
-Which external actors influence whether the result can be achieved?
-This step helps the individual understand the execution system surrounding the expectation — they are not delivering alone, and the leader is confirming that the full chain has been considered.
-</a:t>
-            </a:r>
-          </a:p>
-          <a:p>
-            <a:r>
-              <a:rPr lang="en-US" dirty="0"/>
-              <a:t>The final step confirms that the individual accepts responsibility for ensuring the outcome is delivered. </a:t>
-            </a:r>
-          </a:p>
-          <a:p>
-            <a:r>
-              <a:rPr lang="en-US" dirty="0"/>
-              <a:t>This is the moment the expectation moves from instruction to commitment.</a:t>
-            </a:r>
-          </a:p>
-          <a:p>
-            <a:pPr marL="0" marR="0" lvl="0" indent="0" algn="l" defTabSz="914400" rtl="0" eaLnBrk="1" fontAlgn="auto" latinLnBrk="0" hangingPunct="1">
-              <a:lnSpc>
-                <a:spcPct val="100000"/>
-              </a:lnSpc>
-              <a:spcBef>
-                <a:spcPts val="0"/>
-              </a:spcBef>
-              <a:spcAft>
-                <a:spcPts val="0"/>
-              </a:spcAft>
-              <a:buClrTx/>
-              <a:buSzTx/>
-              <a:buFontTx/>
-              <a:buNone/>
-              <a:tabLst/>
-              <a:defRPr/>
-            </a:pPr>
-            <a:r>
-              <a:rPr lang="en-GB" dirty="0"/>
-              <a:t>The leader verifies that the individual understands their role in driving the result and accepts ownership of coordinating the work required to achieve it.</a:t>
-            </a:r>
-          </a:p>
-          <a:p>
-            <a:r>
-              <a:rPr lang="en-US" dirty="0"/>
-              <a:t>The leader asks the Alignment Question:
-“On a scale of 1–10, how aligned are you with the expectation for you to deliver this outcome?”
-A score of 9 or higher indicates that the expectation has moved into genuine ownership of delivery. The leader can proceed with confidence that the individual has consciously accepted responsibility for the result.
-A score below 9 means there is unresolved concern between the expectation and the individual’s readiness to own it. The leader moves immediately into the Score → Evaluate → Resolve sequence to identify and address the source of misalignment before execution begins.
-</a:t>
-            </a:r>
-          </a:p>
-        </p:txBody>
-      </p:sp>
-      <p:sp>
-        <p:nvSpPr>
-          <p:cNvPr id="4" name="Slide Number Placeholder 3"/>
-          <p:cNvSpPr>
-            <a:spLocks noGrp="1"/>
-          </p:cNvSpPr>
-          <p:nvPr>
-            <p:ph type="sldNum" sz="quarter" idx="10"/>
-          </p:nvPr>
-        </p:nvSpPr>
-        <p:spPr/>
-        <p:txBody>
-          <a:bodyPr/>
-          <a:lstStyle/>
-          <a:p>
-            <a:fld id="{F7021451-1387-4CA6-816F-3879F97B5CBC}" type="slidenum">
-              <a:rPr lang="en-US"/>
-              <a:t>19</a:t>
             </a:fld>
             <a:endParaRPr lang="en-US"/>
           </a:p>
@@ -2437,13 +2228,34 @@
           <a:lstStyle/>
           <a:p>
             <a:r>
-              <a:rPr lang="en-US" dirty="0"/>
-              <a:t>KEY LEARNING OUTCOMES (identical in the participant and facilitator files)
-1. Articulate performance expectations that are clear, strategically relevant and consistent with enterprise outcomes.
-2. Evaluate the readiness of individuals and teams to fulfil their strategic responsibilities.
-3. Recognise the contribution relationships and dependencies that influence organisational performance.
-4. Demonstrate shared ownership and mutual accountability for agreed results.
-Each section slide carries that section’s two learning outcomes.</a:t>
+              <a:t>KEY LEARNING OUTCOMES (identical in the participant and facilitator files)</a:t>
+            </a:r>
+          </a:p>
+          <a:p/>
+          <a:p>
+            <a:r>
+              <a:t>1. Establish performance expectations linked to enterprise outcomes and mapped contributions.</a:t>
+            </a:r>
+          </a:p>
+          <a:p>
+            <a:r>
+              <a:t>2. Test clarity, capability and commitment across the Human and Organisational Operating Systems.</a:t>
+            </a:r>
+          </a:p>
+          <a:p>
+            <a:r>
+              <a:t>3. Identify cross-functional dependencies and agree accountability for enabling conditions.</a:t>
+            </a:r>
+          </a:p>
+          <a:p>
+            <a:r>
+              <a:t>4. Demonstrate shared ownership and mutual accountability for agreed results.</a:t>
+            </a:r>
+          </a:p>
+          <a:p/>
+          <a:p>
+            <a:r>
+              <a:t>Each section slide carries that section’s two learning outcomes.</a:t>
             </a:r>
           </a:p>
         </p:txBody>
@@ -2529,250 +2341,189 @@
           <a:lstStyle/>
           <a:p>
             <a:r>
-              <a:rPr lang="en-GB" b="1" dirty="0"/>
-              <a:t>4.2 — PRACTISING THE ALIGNMENT DIALOGUE (ROLE PLAY IN CLASS)</a:t>
-            </a:r>
-          </a:p>
-          <a:p>
-            <a:endParaRPr lang="en-GB" dirty="0"/>
-          </a:p>
-          <a:p>
-            <a:r>
-              <a:rPr lang="en-GB" dirty="0"/>
+              <a:t>4.1 — PRACTISING THE ALIGNMENT DIALOGUE (ROLE PLAY IN CLASS)</a:t>
+            </a:r>
+          </a:p>
+          <a:p/>
+          <a:p>
+            <a:r>
               <a:t>Participants practise the Alignment Dialogue with the GROW model, both taught in part 1.4. You run this role play in the live session, between any two roles that you choose. Nothing is entered on the portal during the role play.</a:t>
             </a:r>
           </a:p>
-          <a:p>
-            <a:endParaRPr lang="en-GB" dirty="0"/>
-          </a:p>
-          <a:p>
-            <a:r>
-              <a:rPr lang="en-GB" b="1" dirty="0"/>
+          <a:p/>
+          <a:p>
+            <a:r>
               <a:t>HOW TO RUN IT:</a:t>
             </a:r>
           </a:p>
-          <a:p>
-            <a:endParaRPr lang="en-GB" dirty="0"/>
-          </a:p>
-          <a:p>
-            <a:r>
-              <a:rPr lang="en-GB" b="1" dirty="0"/>
+          <a:p/>
+          <a:p>
+            <a:r>
               <a:t>1. Prepare three things.</a:t>
             </a:r>
           </a:p>
           <a:p>
             <a:r>
-              <a:rPr lang="en-GB" dirty="0"/>
-              <a:t>The expectation. One Key Result. Use the example of part 4.1, “Reduce complaint resolution time from 48 hours to 12 hours”, or a Key Result from a group’s Unit 3 Enterprise OKRs.</a:t>
-            </a:r>
-          </a:p>
-          <a:p>
-            <a:r>
-              <a:rPr lang="en-GB" dirty="0"/>
+              <a:t>The expectation. One Key Result. Use the example “Reduce complaint resolution time from 48 hours to 12 hours”, or a Key Result from a group’s Unit 3 Enterprise OKRs.</a:t>
+            </a:r>
+          </a:p>
+          <a:p>
+            <a:r>
               <a:t>The two roles for each round. One is the leader who establishes the expectation. The other is the owner who must deliver it. Any two roles work: CEO and COO, COO and Head of Customer Service, CFO and Head of Procurement, or an executive and the board chair.</a:t>
             </a:r>
           </a:p>
           <a:p>
             <a:r>
-              <a:rPr lang="en-GB" dirty="0"/>
-              <a:t>The owner brief for each round. It gives the owner’s score, the concerns behind it and what moves the owner to a 9 or 10. Two briefs for the part 4.1 example are below. Write your own in the same pattern for the roles you choose.</a:t>
-            </a:r>
-          </a:p>
-          <a:p>
-            <a:endParaRPr lang="en-GB" dirty="0"/>
-          </a:p>
-          <a:p>
-            <a:r>
-              <a:rPr lang="en-GB" b="1" dirty="0"/>
+              <a:t>The owner brief for each round. It gives the owner’s score, the concerns behind it and what moves the owner to a 9 or 10. Two briefs for this example are below. Write your own in the same pattern for the roles you choose.</a:t>
+            </a:r>
+          </a:p>
+          <a:p/>
+          <a:p>
+            <a:r>
               <a:t>2. Set it up.</a:t>
             </a:r>
           </a:p>
           <a:p>
             <a:r>
-              <a:rPr lang="en-GB" dirty="0"/>
               <a:t>Say: "We will now practise the Alignment Dialogue on one expectation. Listen for the four GROW stages." State the expectation and name the two roles.</a:t>
             </a:r>
           </a:p>
-          <a:p>
-            <a:endParaRPr lang="en-GB" dirty="0"/>
-          </a:p>
-          <a:p>
-            <a:r>
-              <a:rPr lang="en-GB" b="1" dirty="0"/>
+          <a:p/>
+          <a:p>
+            <a:r>
               <a:t>3. Give the observers their task.</a:t>
             </a:r>
           </a:p>
           <a:p>
             <a:r>
-              <a:rPr lang="en-GB" dirty="0"/>
               <a:t>Everyone who is not in a role posts in the chat each GROW stage as they hear it (G, R, O or W) and the question that opened it.</a:t>
             </a:r>
           </a:p>
-          <a:p>
-            <a:endParaRPr lang="en-GB" dirty="0"/>
-          </a:p>
-          <a:p>
-            <a:r>
-              <a:rPr lang="en-GB" b="1" dirty="0"/>
+          <a:p/>
+          <a:p>
+            <a:r>
               <a:t>4. Round 1 · You demonstrate.</a:t>
             </a:r>
           </a:p>
           <a:p>
             <a:r>
-              <a:rPr lang="en-GB" dirty="0"/>
               <a:t>You play the leader. A volunteer plays the owner. Send the volunteer the owner brief in a private chat message. Connect the expectation to the Future in one sentence, state the outcome, then ask the alignment question. Work through Score → Evaluate → Resolve with the GROW questions, and end by asking the alignment question again.</a:t>
             </a:r>
           </a:p>
-          <a:p>
-            <a:endParaRPr lang="en-GB" dirty="0"/>
-          </a:p>
-          <a:p>
-            <a:r>
-              <a:rPr lang="en-GB" b="1" dirty="0"/>
+          <a:p/>
+          <a:p>
+            <a:r>
               <a:t>5. Pause.</a:t>
             </a:r>
           </a:p>
           <a:p>
             <a:r>
-              <a:rPr lang="en-GB" dirty="0"/>
               <a:t>Ask the observers: "Which question moved the score?" Read two answers from the chat.</a:t>
             </a:r>
           </a:p>
-          <a:p>
-            <a:endParaRPr lang="en-GB" dirty="0"/>
-          </a:p>
-          <a:p>
-            <a:r>
-              <a:rPr lang="en-GB" b="1" dirty="0"/>
+          <a:p/>
+          <a:p>
+            <a:r>
               <a:t>6. Round 2 · Participants lead.</a:t>
             </a:r>
           </a:p>
           <a:p>
             <a:r>
-              <a:rPr lang="en-GB" dirty="0"/>
               <a:t>One volunteer plays the leader and a second volunteer plays the owner, in the roles you chose. Send the owner brief to the owner in a private chat message. Run further rounds with other roles as you choose.</a:t>
             </a:r>
           </a:p>
-          <a:p>
-            <a:endParaRPr lang="en-GB" dirty="0"/>
-          </a:p>
-          <a:p>
-            <a:r>
-              <a:rPr lang="en-GB" b="1" dirty="0"/>
+          <a:p/>
+          <a:p>
+            <a:r>
               <a:t>7. Debrief.</a:t>
             </a:r>
           </a:p>
           <a:p>
             <a:r>
-              <a:rPr lang="en-GB" dirty="0"/>
               <a:t>Ask: "What did the leader do when the score was low?" "Which concern would have stayed hidden without ‘What else?’" "What felt unfamiliar about asking for a score?"</a:t>
             </a:r>
           </a:p>
-          <a:p>
-            <a:endParaRPr lang="en-GB" dirty="0"/>
-          </a:p>
-          <a:p>
-            <a:r>
-              <a:rPr lang="en-GB" b="1" dirty="0"/>
+          <a:p/>
+          <a:p>
+            <a:r>
               <a:t>8. Point to the Portfolio work.</a:t>
             </a:r>
           </a:p>
           <a:p>
             <a:r>
-              <a:rPr lang="en-GB" dirty="0"/>
-              <a:t>Say: "On the portal, in part 4.2, you prepare an Alignment Dialogue with your board chair on one of your own Key Results."</a:t>
-            </a:r>
-          </a:p>
-          <a:p>
-            <a:endParaRPr lang="en-GB" dirty="0"/>
-          </a:p>
-          <a:p>
-            <a:r>
-              <a:rPr lang="en-GB" b="1" dirty="0"/>
+              <a:t>Say: "On the portal, in part 4.1, you prepare an Alignment Dialogue with your board chair on one of your own Key Results."</a:t>
+            </a:r>
+          </a:p>
+          <a:p/>
+          <a:p>
+            <a:r>
               <a:t>Owner briefs for the example of part 4.1:</a:t>
             </a:r>
           </a:p>
           <a:p>
             <a:r>
-              <a:rPr lang="en-GB" dirty="0"/>
               <a:t>Owner brief · example A: You give a 7. The outcome is clear to you. Your concern is that the billing team must answer customer queries on the same day, and nobody has agreed this with them. You move to a 9 when the leader agrees to establish that expectation with the Head of Billing.</a:t>
             </a:r>
           </a:p>
           <a:p>
             <a:r>
-              <a:rPr lang="en-GB" dirty="0"/>
               <a:t>Owner brief · example B: You give a 5. You have two concerns. First, you do not know how “resolved” will be measured. Second, your team has three vacancies. Give only the first concern until the leader asks “What else?” You move to a 9 when success is defined and the two of you have agreed how the vacancies will be covered.</a:t>
             </a:r>
           </a:p>
-          <a:p>
-            <a:endParaRPr lang="en-GB" dirty="0"/>
-          </a:p>
-          <a:p>
-            <a:r>
-              <a:rPr lang="en-GB" b="1" dirty="0"/>
+          <a:p/>
+          <a:p>
+            <a:r>
               <a:t>Watch for:</a:t>
             </a:r>
           </a:p>
           <a:p>
             <a:r>
-              <a:rPr lang="en-GB" dirty="0"/>
               <a:t>The leader defends the target or argues with the score. Stop the round and ask the leader to return to "What influenced the score you gave?"</a:t>
             </a:r>
           </a:p>
           <a:p>
             <a:r>
-              <a:rPr lang="en-GB" dirty="0"/>
               <a:t>The leader offers solutions before asking for the owner’s options. Ask: "Whose idea was that?"</a:t>
             </a:r>
           </a:p>
           <a:p>
             <a:r>
-              <a:rPr lang="en-GB" dirty="0"/>
               <a:t>The dialogue ends without the alignment question being asked again. Ask: "How do you know where the owner stands now?"</a:t>
             </a:r>
           </a:p>
-          <a:p>
-            <a:endParaRPr lang="en-GB" dirty="0"/>
-          </a:p>
-          <a:p>
-            <a:r>
-              <a:rPr lang="en-GB" b="1" dirty="0"/>
+          <a:p/>
+          <a:p>
+            <a:r>
               <a:t>ON THE PORTAL, AFTER THE TEACHING:</a:t>
             </a:r>
           </a:p>
           <a:p>
             <a:r>
-              <a:rPr lang="en-GB" dirty="0"/>
               <a:t>Each participant completes part 4.2 of their own file alone, as Portfolio work:</a:t>
             </a:r>
           </a:p>
           <a:p>
             <a:r>
-              <a:rPr lang="en-GB" dirty="0"/>
               <a:t>1. They choose from a drop-down list the Key Result for which they may need an alignment dialogue with their board chair. The list holds the Key Results their group confirmed in Unit 3.</a:t>
             </a:r>
           </a:p>
           <a:p>
             <a:r>
-              <a:rPr lang="en-GB" dirty="0"/>
               <a:t>2. They read the scenario: the board chair has disagreed with the current metric and timeframe of that Key Result and gives a 5.</a:t>
             </a:r>
           </a:p>
           <a:p>
             <a:r>
-              <a:rPr lang="en-GB" dirty="0"/>
               <a:t>3. They write their side of the dialogue under each GROW stage (Goal, Reality, Options, Will), with the questions they ask in their own words.</a:t>
             </a:r>
           </a:p>
           <a:p>
             <a:r>
-              <a:rPr lang="en-GB" dirty="0"/>
               <a:t>4. Under Will they state what they and the chair agree to do and how they confirm that the chair has reached a 10.</a:t>
             </a:r>
           </a:p>
           <a:p>
             <a:r>
-              <a:rPr lang="en-GB" dirty="0"/>
               <a:t>The work becomes part of the participant’s Learning Portfolio. It reaches you when the participant selects Submit to Facilitator at the end of the unit.</a:t>
             </a:r>
           </a:p>
@@ -2854,176 +2605,118 @@
           <a:lstStyle/>
           <a:p>
             <a:r>
-              <a:rPr lang="en-GB" b="1" dirty="0"/>
-              <a:t>SECTION 4 REFLECTIONS</a:t>
-            </a:r>
-          </a:p>
-          <a:p>
-            <a:endParaRPr lang="en-GB" dirty="0"/>
-          </a:p>
-          <a:p>
-            <a:r>
-              <a:rPr lang="en-GB" b="1" dirty="0"/>
+              <a:t>SECTION 4 · PORTFOLIO WORK</a:t>
+            </a:r>
+          </a:p>
+          <a:p/>
+          <a:p>
+            <a:r>
               <a:t>HOW TO USE THIS SLIDE:</a:t>
             </a:r>
           </a:p>
-          <a:p>
-            <a:endParaRPr lang="en-GB" dirty="0"/>
-          </a:p>
-          <a:p>
-            <a:r>
-              <a:rPr lang="en-GB" b="1" dirty="0"/>
-              <a:t>1. Show the slide and read the first prompt aloud.</a:t>
-            </a:r>
-          </a:p>
-          <a:p>
-            <a:r>
-              <a:rPr lang="en-GB" dirty="0"/>
-              <a:t>4.1 Reflection — Which Step Do You Most Often Skip?: "Of the four steps, which one do you most often move through too quickly? What would change if you gave it more time?"</a:t>
-            </a:r>
-          </a:p>
-          <a:p>
-            <a:endParaRPr lang="en-GB" dirty="0"/>
-          </a:p>
-          <a:p>
-            <a:r>
-              <a:rPr lang="en-GB" b="1" dirty="0"/>
-              <a:t>2. Explain the Portfolio work of part 4.2.</a:t>
-            </a:r>
-          </a:p>
-          <a:p>
-            <a:r>
-              <a:rPr lang="en-GB" dirty="0"/>
-              <a:t>Say: "In part 4.2 you prepare an Alignment Dialogue with your board chair, using the GROW model.</a:t>
-            </a:r>
-          </a:p>
-          <a:p>
-            <a:r>
-              <a:rPr lang="en-GB" dirty="0"/>
+          <a:p/>
+          <a:p>
+            <a:r>
+              <a:t>1. Explain the Portfolio work of part 4.1.</a:t>
+            </a:r>
+          </a:p>
+          <a:p>
+            <a:r>
+              <a:t>Say: "In part 4.1 you prepare an Alignment Dialogue with your board chair, using the GROW model.</a:t>
+            </a:r>
+          </a:p>
+          <a:p>
+            <a:r>
               <a:t>You choose the Key Result for which you may need that dialogue.</a:t>
             </a:r>
           </a:p>
           <a:p>
             <a:r>
-              <a:rPr lang="en-GB" dirty="0"/>
               <a:t>The scenario is on your page: your board chair has disagreed with the current metric and timeframe of that Key Result and gives a 5.</a:t>
             </a:r>
           </a:p>
           <a:p>
             <a:r>
-              <a:rPr lang="en-GB" dirty="0"/>
               <a:t>You write your side of the dialogue under Goal, Reality, Options and Will, to move your chair to a 10."</a:t>
             </a:r>
           </a:p>
-          <a:p>
-            <a:endParaRPr lang="en-GB" dirty="0"/>
-          </a:p>
-          <a:p>
-            <a:r>
-              <a:rPr lang="en-GB" b="1" dirty="0"/>
-              <a:t>3. Say what the reflections are for.</a:t>
-            </a:r>
-          </a:p>
-          <a:p>
-            <a:r>
-              <a:rPr lang="en-GB" dirty="0"/>
-              <a:t>Point learners to the portal section that they will be required to complete with as much depth as possible.</a:t>
-            </a:r>
-          </a:p>
-          <a:p>
-            <a:r>
-              <a:rPr lang="en-GB" dirty="0"/>
-              <a:t>The reflections build the learning portfolio they receive at the end of the programme.</a:t>
-            </a:r>
-          </a:p>
-          <a:p>
-            <a:endParaRPr lang="en-GB" dirty="0"/>
-          </a:p>
-          <a:p>
-            <a:r>
-              <a:rPr lang="en-GB" dirty="0"/>
-              <a:t>Say: "You write the reflection and the Portfolio work on the portal after the teaching, with as much depth as you can."</a:t>
-            </a:r>
-          </a:p>
-          <a:p>
-            <a:endParaRPr lang="en-GB" dirty="0"/>
-          </a:p>
-          <a:p>
-            <a:r>
-              <a:rPr lang="en-GB" b="1" dirty="0"/>
-              <a:t>4. Set the standard.</a:t>
-            </a:r>
-          </a:p>
-          <a:p>
-            <a:r>
-              <a:rPr lang="en-GB" dirty="0"/>
+          <a:p/>
+          <a:p>
+            <a:r>
+              <a:t>2. Say what the Portfolio work is for.</a:t>
+            </a:r>
+          </a:p>
+          <a:p>
+            <a:r>
+              <a:t>The Portfolio work builds the learning portfolio participants receive at the end of the programme.</a:t>
+            </a:r>
+          </a:p>
+          <a:p>
+            <a:r>
+              <a:t>Say: "You complete the Portfolio work on the portal after the teaching, with as much depth as you can."</a:t>
+            </a:r>
+          </a:p>
+          <a:p/>
+          <a:p>
+            <a:r>
+              <a:t>3. Set the standard.</a:t>
+            </a:r>
+          </a:p>
+          <a:p>
+            <a:r>
               <a:t>Say: "Write the questions you would ask in your own words. A question you would never say aloud does not belong in your dialogue."</a:t>
             </a:r>
           </a:p>
           <a:p>
             <a:r>
-              <a:rPr lang="en-GB" dirty="0"/>
               <a:t>Watch for: answers that argue the case for the metric. Ask which GROW question comes first.</a:t>
             </a:r>
           </a:p>
-          <a:p>
-            <a:endParaRPr lang="en-GB" dirty="0"/>
-          </a:p>
-          <a:p>
-            <a:r>
-              <a:rPr lang="en-GB" b="1" dirty="0"/>
-              <a:t>5. Bridge to Section 5.</a:t>
-            </a:r>
-          </a:p>
-          <a:p>
-            <a:r>
-              <a:rPr lang="en-GB" dirty="0"/>
-              <a:t>Say: "You have practised the dialogue. In Section 5 your group establishes delivery expectations for two of its own Objectives."</a:t>
-            </a:r>
-          </a:p>
-          <a:p>
-            <a:endParaRPr lang="en-GB" dirty="0"/>
-          </a:p>
-          <a:p>
-            <a:r>
-              <a:rPr lang="en-GB" b="1" dirty="0"/>
+          <a:p/>
+          <a:p>
+            <a:r>
+              <a:t>4. Bridge to Section 5.</a:t>
+            </a:r>
+          </a:p>
+          <a:p>
+            <a:r>
+              <a:t>Say: "You have practised the dialogue. In Section 5 your group establishes delivery expectations for two contributions from its Contribution Map, for the people and for the organisation."</a:t>
+            </a:r>
+          </a:p>
+          <a:p/>
+          <a:p>
+            <a:r>
               <a:t>ON THE PORTAL, AFTER THE TEACHING:</a:t>
             </a:r>
           </a:p>
           <a:p>
             <a:r>
-              <a:rPr lang="en-GB" dirty="0"/>
-              <a:t>Participants write the 4.1 reflection in Section 4 of the participant file, at the foot of part 4.1.</a:t>
-            </a:r>
-          </a:p>
-          <a:p>
-            <a:r>
-              <a:rPr lang="en-GB" dirty="0"/>
-              <a:t>Each participant completes part 4.2 of their own file alone, as Portfolio work:</a:t>
-            </a:r>
-          </a:p>
-          <a:p>
-            <a:r>
-              <a:rPr lang="en-GB" dirty="0"/>
+              <a:t>Each participant completes part 4.1 of their own file alone, as Portfolio work:</a:t>
+            </a:r>
+          </a:p>
+          <a:p>
+            <a:r>
               <a:t>1. They choose from a drop-down list the Key Result for which they may need an alignment dialogue with their board chair. The list holds the Key Results their group confirmed in Unit 3.</a:t>
             </a:r>
           </a:p>
           <a:p>
             <a:r>
-              <a:rPr lang="en-GB" dirty="0"/>
               <a:t>2. They read the scenario: the board chair has disagreed with the current metric and timeframe of that Key Result and gives a 5.</a:t>
             </a:r>
           </a:p>
           <a:p>
             <a:r>
-              <a:rPr lang="en-GB" dirty="0"/>
               <a:t>3. They write their side of the dialogue under each GROW stage (Goal, Reality, Options, Will), with the questions they ask in their own words.</a:t>
             </a:r>
           </a:p>
           <a:p>
             <a:r>
-              <a:rPr lang="en-GB" dirty="0"/>
               <a:t>4. Under Will they state what they and the chair agree to do and how they confirm that the chair has reached a 10.</a:t>
+            </a:r>
+          </a:p>
+          <a:p>
+            <a:r>
+              <a:t>The work becomes part of the participant’s Learning Portfolio. It reaches you when the participant selects Submit to Facilitator at the end of the unit.</a:t>
             </a:r>
           </a:p>
         </p:txBody>
@@ -3109,164 +2802,133 @@
           <a:lstStyle/>
           <a:p>
             <a:r>
-              <a:rPr lang="en-GB" b="1" dirty="0"/>
               <a:t>SECTION 5 · APPLICATION — IN PRACTICE</a:t>
             </a:r>
           </a:p>
-          <a:p>
-            <a:endParaRPr lang="en-GB" dirty="0"/>
-          </a:p>
-          <a:p>
-            <a:r>
-              <a:rPr lang="en-GB" b="1" dirty="0"/>
+          <a:p/>
+          <a:p>
+            <a:r>
               <a:t>HOW THIS SECTION RUNS:</a:t>
             </a:r>
           </a:p>
           <a:p>
             <a:r>
-              <a:rPr lang="en-GB" dirty="0"/>
               <a:t>This is group work and Capstone work. Section 5 has two exercises:</a:t>
             </a:r>
           </a:p>
           <a:p>
             <a:r>
-              <a:rPr lang="en-GB" dirty="0"/>
-              <a:t>5.1 · Building the Expectation Architecture. Each group takes two Objectives, with one Key Result each, through the four steps.</a:t>
-            </a:r>
-          </a:p>
-          <a:p>
-            <a:r>
-              <a:rPr lang="en-GB" dirty="0"/>
+              <a:t>5.1 · Building the Expectation Architecture. Each group selects two contributions from the Contribution Map it built in Unit 6 and takes each through the four steps, establishing a human performance expectation and the supporting ESRG expectations.</a:t>
+            </a:r>
+          </a:p>
+          <a:p>
+            <a:r>
               <a:t>5.2 · Conducting the Alignment Dialogue with the Board Chair. Each group prepares the dialogue that moves its board chair to a 10 on one Key Result.</a:t>
             </a:r>
           </a:p>
           <a:p>
             <a:r>
-              <a:rPr lang="en-GB" dirty="0"/>
               <a:t>The group agrees each entry and one member acts as scribe. Every member then types the agreed entries into their own page, in the session or after it.</a:t>
             </a:r>
           </a:p>
           <a:p>
             <a:r>
-              <a:rPr lang="en-GB" dirty="0"/>
               <a:t>Each participant then reads the group’s record at the foot of the section and selects Confirm. The confirmed record feeds the team’s Capstone Blueprint.</a:t>
             </a:r>
           </a:p>
-          <a:p>
-            <a:endParaRPr lang="en-GB" dirty="0"/>
-          </a:p>
-          <a:p>
-            <a:r>
-              <a:rPr lang="en-GB" b="1" dirty="0"/>
+          <a:p/>
+          <a:p>
+            <a:r>
               <a:t>SECTION LEARNING OUTCOMES:</a:t>
             </a:r>
           </a:p>
           <a:p>
             <a:r>
-              <a:rPr lang="en-GB" dirty="0"/>
-              <a:t>1. Establish delivery expectations that secure personal ownership of agreed results.</a:t>
-            </a:r>
-          </a:p>
-          <a:p>
-            <a:r>
-              <a:rPr lang="en-GB" dirty="0"/>
-              <a:t>2. Confirm the contributors and commitments that make mutual accountability visible.</a:t>
-            </a:r>
-          </a:p>
-          <a:p>
-            <a:endParaRPr lang="en-GB" dirty="0"/>
-          </a:p>
-          <a:p>
-            <a:r>
-              <a:rPr lang="en-GB" b="1" dirty="0"/>
+              <a:t>1. Establish expectations for the contributions mapped in the Capstone.</a:t>
+            </a:r>
+          </a:p>
+          <a:p>
+            <a:r>
+              <a:t>2. Record agreed commitments, ESRG conditions and alignment actions in the Capstone Blueprint.</a:t>
+            </a:r>
+          </a:p>
+          <a:p/>
+          <a:p>
+            <a:r>
               <a:t>HOW TO OPEN THE SECTION:</a:t>
             </a:r>
           </a:p>
-          <a:p>
-            <a:endParaRPr lang="en-GB" dirty="0"/>
-          </a:p>
-          <a:p>
-            <a:r>
-              <a:rPr lang="en-GB" b="1" dirty="0"/>
+          <a:p/>
+          <a:p>
+            <a:r>
               <a:t>1. Say what the section does.</a:t>
             </a:r>
           </a:p>
           <a:p>
             <a:r>
-              <a:rPr lang="en-GB" dirty="0"/>
               <a:t>Say: "Section 5 has two exercises.</a:t>
             </a:r>
           </a:p>
           <a:p>
             <a:r>
-              <a:rPr lang="en-GB" dirty="0"/>
-              <a:t>In 5.1 your group builds the Expectation Architecture for two of its Objectives.</a:t>
-            </a:r>
-          </a:p>
-          <a:p>
-            <a:r>
-              <a:rPr lang="en-GB" dirty="0"/>
+              <a:t>In 5.1 your group builds the Expectation Architecture for two contributions from its Contribution Map, for the people and for the organisation.</a:t>
+            </a:r>
+          </a:p>
+          <a:p>
+            <a:r>
               <a:t>In 5.2 your group prepares the Alignment Dialogue with your board chair."</a:t>
             </a:r>
           </a:p>
-          <a:p>
-            <a:endParaRPr lang="en-GB" dirty="0"/>
-          </a:p>
-          <a:p>
-            <a:r>
-              <a:rPr lang="en-GB" b="1" dirty="0"/>
+          <a:p/>
+          <a:p>
+            <a:r>
               <a:t>2. Say how the group works.</a:t>
             </a:r>
           </a:p>
           <a:p>
             <a:r>
-              <a:rPr lang="en-GB" dirty="0"/>
               <a:t>Say: "Both exercises are group work.</a:t>
             </a:r>
           </a:p>
           <a:p>
             <a:r>
-              <a:rPr lang="en-GB" dirty="0"/>
               <a:t>Your group agrees each entry.</a:t>
             </a:r>
           </a:p>
           <a:p>
             <a:r>
-              <a:rPr lang="en-GB" dirty="0"/>
               <a:t>One member acts as scribe.</a:t>
             </a:r>
           </a:p>
           <a:p>
             <a:r>
-              <a:rPr lang="en-GB" dirty="0"/>
               <a:t>Every member then types the agreed entries into their own page, in the session or after it."</a:t>
             </a:r>
           </a:p>
-          <a:p>
-            <a:endParaRPr lang="en-GB" dirty="0"/>
-          </a:p>
-          <a:p>
-            <a:r>
-              <a:rPr lang="en-GB" b="1" dirty="0"/>
+          <a:p/>
+          <a:p>
+            <a:r>
               <a:t>3. Say where the work goes.</a:t>
             </a:r>
           </a:p>
           <a:p>
             <a:r>
-              <a:rPr lang="en-GB" dirty="0"/>
               <a:t>Say: "This is Capstone work. You read your group’s record at the foot of the section and select Confirm. Your confirmed record feeds your team’s Capstone Blueprint."</a:t>
             </a:r>
           </a:p>
           <a:p>
             <a:r>
-              <a:rPr lang="en-GB" dirty="0"/>
               <a:t>Your role in this section: Guide how the work is completed. The Capstone work is reviewed independently at graduation.</a:t>
             </a:r>
           </a:p>
           <a:p>
             <a:r>
-              <a:rPr lang="en-GB" dirty="0"/>
-              <a:t>The drop-down lists hold the group’s Enterprise OKRs and its Success in Practice statements. Each group confirms them in Unit 3, part 5.2, and in Unit 2 first.</a:t>
+              <a:t>Before the group starts: The drop-down lists of 5.1 hold the functions of the group’s Contribution Map (Unit 6, Section 5) and its Success in Practice statements (Unit 2). The list of 5.2 holds the Key Results of its Enterprise OKRs (Unit 3). Each group confirms them in those units first.</a:t>
+            </a:r>
+          </a:p>
+          <a:p>
+            <a:r>
+              <a:t>A complete record: Every expectation has a clear enterprise line of sight, an accountable human owner, named ESRG enabling owners, agreed evidence and a documented alignment outcome.</a:t>
             </a:r>
           </a:p>
         </p:txBody>
@@ -3352,155 +3014,194 @@
           <a:lstStyle/>
           <a:p>
             <a:r>
-              <a:rPr lang="en-GB" b="1" dirty="0"/>
               <a:t>5.1 — BUILDING THE EXPECTATION ARCHITECTURE (CAPSTONE WORK)</a:t>
             </a:r>
           </a:p>
-          <a:p>
-            <a:endParaRPr lang="en-GB" dirty="0"/>
-          </a:p>
-          <a:p>
-            <a:r>
-              <a:rPr lang="en-GB" b="1" dirty="0"/>
+          <a:p/>
+          <a:p>
+            <a:r>
               <a:t>HOW TO TEACH IT:</a:t>
             </a:r>
           </a:p>
-          <a:p>
-            <a:endParaRPr lang="en-GB" dirty="0"/>
-          </a:p>
-          <a:p>
-            <a:r>
-              <a:rPr lang="en-GB" b="1" dirty="0"/>
+          <a:p/>
+          <a:p>
+            <a:r>
               <a:t>1. Say what the group does.</a:t>
             </a:r>
           </a:p>
           <a:p>
             <a:r>
-              <a:rPr lang="en-GB" dirty="0"/>
-              <a:t>Say: "Each group takes two Objectives, with one Key Result each, through the four steps."</a:t>
-            </a:r>
-          </a:p>
-          <a:p>
-            <a:endParaRPr lang="en-GB" dirty="0"/>
-          </a:p>
-          <a:p>
-            <a:r>
-              <a:rPr lang="en-GB" b="1" dirty="0"/>
+              <a:t>Say: "Each group selects two contributions from the Contribution Map it built in Unit 6 and takes each through the four steps. For each one you establish a human performance expectation and the supporting ESRG expectations."</a:t>
+            </a:r>
+          </a:p>
+          <a:p/>
+          <a:p>
+            <a:r>
               <a:t>2. Step 1 · Start With the Future.</a:t>
             </a:r>
           </a:p>
           <a:p>
             <a:r>
-              <a:rPr lang="en-GB" dirty="0"/>
-              <a:t>Say: "From the drop-down lists, choose two Objectives. For each one, choose one Key Result that belongs to it and the Success in Practice statement it serves.</a:t>
-            </a:r>
-          </a:p>
-          <a:p>
-            <a:r>
-              <a:rPr lang="en-GB" dirty="0"/>
-              <a:t>Name the owner of each Key Result: the executive role that must make sure it is delivered.</a:t>
-            </a:r>
-          </a:p>
-          <a:p>
-            <a:r>
-              <a:rPr lang="en-GB" dirty="0"/>
-              <a:t>For each Key Result, write the part of that Future it serves.</a:t>
-            </a:r>
-          </a:p>
-          <a:p>
-            <a:r>
-              <a:rPr lang="en-GB" dirty="0"/>
-              <a:t>Write the leader framing: the sentence that you, as the leader, say to the owner to connect the Key Result to that Future."</a:t>
-            </a:r>
-          </a:p>
-          <a:p>
-            <a:r>
-              <a:rPr lang="en-GB" dirty="0"/>
-              <a:t>The lists hold the Enterprise OKRs the group confirmed in Unit 3 and the Success in Practice statements it confirmed in Unit 2.</a:t>
-            </a:r>
-          </a:p>
-          <a:p>
-            <a:endParaRPr lang="en-GB" dirty="0"/>
-          </a:p>
-          <a:p>
-            <a:r>
-              <a:rPr lang="en-GB" b="1" dirty="0"/>
+              <a:t>The lesson participants see: Step 1 · Start With the Future · Connect the expectation to the organisation’s Success in Practice (SiP) — so the individual understands why the outcome matters. When expectations begin with the Future, individuals understand the contribution their work makes to the broader direction.</a:t>
+            </a:r>
+          </a:p>
+          <a:p>
+            <a:r>
+              <a:t>Say: "From the first drop-down list, choose two contributions. The list holds the functions your group mapped in Unit 6 for its enterprise Key Result.</a:t>
+            </a:r>
+          </a:p>
+          <a:p>
+            <a:r>
+              <a:t>For each contribution, choose the Success in Practice statement it serves.</a:t>
+            </a:r>
+          </a:p>
+          <a:p>
+            <a:r>
+              <a:t>Name the owner of each contribution: the role that must make sure it is delivered.</a:t>
+            </a:r>
+          </a:p>
+          <a:p>
+            <a:r>
+              <a:t>For each contribution, write the part of that Future it serves.</a:t>
+            </a:r>
+          </a:p>
+          <a:p>
+            <a:r>
+              <a:t>Write the leader framing: the sentence that you, as the leader, say to the owner to connect the contribution to that Future."</a:t>
+            </a:r>
+          </a:p>
+          <a:p>
+            <a:r>
+              <a:t>The first list holds the functions of the group's Unit 6 Contribution Map, with the enterprise Key Result they serve. The second holds the Success in Practice statements the group confirmed in Unit 2.</a:t>
+            </a:r>
+          </a:p>
+          <a:p/>
+          <a:p>
+            <a:r>
               <a:t>3. Step 2 · Clarify the Delivery Expectation.</a:t>
             </a:r>
           </a:p>
           <a:p>
             <a:r>
-              <a:rPr lang="en-GB" dirty="0"/>
-              <a:t>Say: "For each Key Result, state what must be delivered, as a result the owner can be held to. State by when the result must be in place. State the standard the result must meet. State how success will be recognised: the evidence you and the owner will both accept."</a:t>
-            </a:r>
-          </a:p>
-          <a:p>
-            <a:endParaRPr lang="en-GB" dirty="0"/>
-          </a:p>
-          <a:p>
-            <a:r>
-              <a:rPr lang="en-GB" b="1" dirty="0"/>
+              <a:t>The lesson participants see: From part 1.2 · Clarity in the Human Operating System · Strategic contribution, performance expectations, performance standard, behavioural expectations and evidence. From part 1.2 · Clarity in the Organisational Operating System (ESRG) · What the Environment, Systems, Resources and Governance must provide for the contribution to be delivered.</a:t>
+            </a:r>
+          </a:p>
+          <a:p>
+            <a:r>
+              <a:t>Say: "Read what your Contribution Map holds for each contribution.</a:t>
+            </a:r>
+          </a:p>
+          <a:p>
+            <a:r>
+              <a:t>For the people (Human Operating System), state what must be delivered, by when, to what standard, how success will be recognised and the behaviours expected.</a:t>
+            </a:r>
+          </a:p>
+          <a:p>
+            <a:r>
+              <a:t>For the organisation (ESRG), state what the Environment, Systems, Resources and Governance must provide, and name the owner of each condition."</a:t>
+            </a:r>
+          </a:p>
+          <a:p>
+            <a:r>
+              <a:t>This is part 1.2 at work: Clarity in the Human Operating System and Clarity in the Organisational Operating System (ESRG).</a:t>
+            </a:r>
+          </a:p>
+          <a:p/>
+          <a:p>
+            <a:r>
               <a:t>4. Step 3 · Identify the Expectations Chain.</a:t>
             </a:r>
           </a:p>
           <a:p>
             <a:r>
-              <a:rPr lang="en-GB" dirty="0"/>
-              <a:t>Say: "For each Key Result, name the Upline contributors and state what the outcome needs from them. Name the Downline contributors and state what the outcome needs from them. Name the External contributors and state what the outcome needs from them. State the coordination these contributors require."</a:t>
-            </a:r>
-          </a:p>
-          <a:p>
-            <a:endParaRPr lang="en-GB" dirty="0"/>
-          </a:p>
-          <a:p>
-            <a:r>
-              <a:rPr lang="en-GB" b="1" dirty="0"/>
+              <a:t>The lesson participants see: From part 1.3 · Upline · Those who authorise, resource or enable delivery: decisions, support, approvals and removal of constraints. From part 1.3 · Downline · Those who perform the work: results, standards, behaviours and evidence of performance. From part 1.3 · Crossline · Those whose contributions are interdependent: handovers, coordination, shared responsibilities and delivery commitments.</a:t>
+            </a:r>
+          </a:p>
+          <a:p>
+            <a:r>
+              <a:t>Say: "For each contribution, name the Upline and state what must be established with them.</a:t>
+            </a:r>
+          </a:p>
+          <a:p>
+            <a:r>
+              <a:t>Name the Downline and state what must be established with them.</a:t>
+            </a:r>
+          </a:p>
+          <a:p>
+            <a:r>
+              <a:t>Name the Crossline and state what must be established with them.</a:t>
+            </a:r>
+          </a:p>
+          <a:p>
+            <a:r>
+              <a:t>State the coordination these contributors require."</a:t>
+            </a:r>
+          </a:p>
+          <a:p/>
+          <a:p>
+            <a:r>
               <a:t>5. Step 4 · Confirm Ownership.</a:t>
             </a:r>
           </a:p>
           <a:p>
             <a:r>
-              <a:rPr lang="en-GB" dirty="0"/>
-              <a:t>Say: "Agree which of you speaks as the leader and which of you answers as the owner of the Key Result. As the leader, ask the alignment question. Record the owner’s score. Where the score is below 9, ask the GROW questions of part 1.4. Record what stands behind the score, the actions agreed and the revised score. Where the first score is 9 or 10, the three boxes below it stay empty."</a:t>
-            </a:r>
-          </a:p>
-          <a:p>
-            <a:endParaRPr lang="en-GB" dirty="0"/>
-          </a:p>
-          <a:p>
-            <a:r>
-              <a:rPr lang="en-GB" b="1" dirty="0"/>
+              <a:t>The lesson participants see: The alignment question · “On a scale of 1–10, how aligned are you with the expectation for you to deliver this outcome?” From part 1.4 · A score of 9 or 10: proceed and confirm the commitment. Below 9: Score → Evaluate → Resolve, with the GROW questions (Goal, Reality, Options, Will). Agree a resolution owner and review date for each constraint. Then ask the alignment question again.</a:t>
+            </a:r>
+          </a:p>
+          <a:p>
+            <a:r>
+              <a:t>Say: "Agree which of you speaks as the leader and which of you answers as the owner of the contribution.</a:t>
+            </a:r>
+          </a:p>
+          <a:p>
+            <a:r>
+              <a:t>As the leader, ask the alignment question. Record the owner’s score.</a:t>
+            </a:r>
+          </a:p>
+          <a:p>
+            <a:r>
+              <a:t>Where the score is below 9, ask the GROW questions of part 1.4. Record what stands behind the score, the actions agreed with their owners and review dates, and the revised score.</a:t>
+            </a:r>
+          </a:p>
+          <a:p>
+            <a:r>
+              <a:t>Where the first score is 9 or 10, the three boxes below it stay empty."</a:t>
+            </a:r>
+          </a:p>
+          <a:p/>
+          <a:p>
+            <a:r>
               <a:t>ON THE PORTAL, AFTER THE TEACHING:</a:t>
             </a:r>
           </a:p>
           <a:p>
             <a:r>
-              <a:rPr lang="en-GB" dirty="0"/>
               <a:t>Participants work as a group in part 5.1 of their own file. This is Capstone work. The group agrees each entry and one member acts as scribe. Every member then types the agreed entries into their own page, in the session or after it.</a:t>
             </a:r>
           </a:p>
           <a:p>
             <a:r>
-              <a:rPr lang="en-GB" dirty="0"/>
-              <a:t>Step 1: For each of the two Objectives, three drop-down lists: the Objective · one Key Result of that Objective · the Success in Practice statement it serves. The lists hold the group’s confirmed Unit 3 Enterprise OKRs and Unit 2 SiP statements. Three boxes: Owner of the Key Result · The part of that Future it serves · Leader framing.</a:t>
-            </a:r>
-          </a:p>
-          <a:p>
-            <a:r>
-              <a:rPr lang="en-GB" dirty="0"/>
-              <a:t>Step 2: For each of the two Objectives, four boxes: What must be delivered · By when · To what standard · How success will be recognised.</a:t>
-            </a:r>
-          </a:p>
-          <a:p>
-            <a:r>
-              <a:rPr lang="en-GB" dirty="0"/>
-              <a:t>Step 3: For each of the two Objectives, two boxes for each chain (Upline, Downline, External): who they are · what the outcome needs from them. One box: Coordination required across these contributors.</a:t>
-            </a:r>
-          </a:p>
-          <a:p>
-            <a:r>
-              <a:rPr lang="en-GB" dirty="0"/>
-              <a:t>Step 4: For each of the two Objectives: Alignment score (1 to 10). Where the score is below 9, three boxes: What stands behind the score · Actions agreed to reach a 9 or 10 · Revised alignment score.</a:t>
+              <a:t>Step 1: For each of the two contributions, two drop-down lists: the contribution (a function of the group’s Unit 6 Contribution Map, shown with its enterprise Key Result) · the Success in Practice statement it serves (Unit 2). Three boxes: Owner of the contribution · The part of that Future it serves · Leader framing.</a:t>
+            </a:r>
+          </a:p>
+          <a:p>
+            <a:r>
+              <a:t>Step 2: For each of the two contributions, the Contribution Map entries shown for reading. For the people, five boxes: What must be delivered · By when · To what standard · How success will be recognised · The behaviours expected. For the organisation, four boxes: Environment · Systems · Resources · Governance, each with what must be provided and who owns it.</a:t>
+            </a:r>
+          </a:p>
+          <a:p>
+            <a:r>
+              <a:t>Step 3: For each of the two contributions, two boxes for each direction (Upline, Downline, Crossline): who they are · what must be established with them. One box: Coordination required across these contributors.</a:t>
+            </a:r>
+          </a:p>
+          <a:p>
+            <a:r>
+              <a:t>Step 4: For each of the two contributions: Alignment score (1 to 10). Where the score is below 9, three boxes: What stands behind the score · Actions agreed to reach a 9 or 10, with an owner and a review date for each · Revised alignment score.</a:t>
+            </a:r>
+          </a:p>
+          <a:p>
+            <a:r>
+              <a:t>A complete record: Every expectation has a clear enterprise line of sight, an accountable human owner, named ESRG enabling owners, agreed evidence and a documented alignment outcome.</a:t>
             </a:r>
           </a:p>
         </p:txBody>
@@ -3859,144 +3560,82 @@
           <a:bodyPr/>
           <a:lstStyle/>
           <a:p>
-            <a:pPr marL="0" marR="0" lvl="0" indent="0" algn="l" defTabSz="914400" rtl="0" eaLnBrk="1" fontAlgn="auto" latinLnBrk="0" hangingPunct="1">
-              <a:lnSpc>
-                <a:spcPct val="100000"/>
-              </a:lnSpc>
-              <a:spcBef>
-                <a:spcPts val="0"/>
-              </a:spcBef>
-              <a:spcAft>
-                <a:spcPts val="0"/>
-              </a:spcAft>
-              <a:buClrTx/>
-              <a:buSzTx/>
-              <a:buFontTx/>
-              <a:buNone/>
-              <a:tabLst/>
-              <a:defRPr/>
-            </a:pPr>
-            <a:r>
-              <a:rPr lang="en-US" dirty="0"/>
-              <a:t>SECTION 1 · AWARENESS — WHAT
-What is Establishing Performance Expectations?
-Naming the distinction between setting and establishing expectations — and the two mechanisms that close the gap between a delivery goal and genuine ownership.
-Section learning outcomes:
-1. </a:t>
-            </a:r>
-            <a:r>
-              <a:rPr lang="en-US" sz="1200" dirty="0">
-                <a:solidFill>
-                  <a:srgbClr val="FFFFFF"/>
-                </a:solidFill>
-                <a:latin typeface="Calibri" pitchFamily="34" charset="0"/>
-                <a:ea typeface="Calibri" pitchFamily="34" charset="-122"/>
-                <a:cs typeface="Calibri" pitchFamily="34" charset="-120"/>
-              </a:rPr>
-              <a:t>Understand the distinction between setting vs establishing expectations</a:t>
-            </a:r>
-            <a:endParaRPr lang="en-US" sz="1200" dirty="0"/>
-          </a:p>
-          <a:p>
-            <a:pPr marL="0" marR="0" lvl="0" indent="0" algn="l" defTabSz="914400" rtl="0" eaLnBrk="1" fontAlgn="auto" latinLnBrk="0" hangingPunct="1">
-              <a:lnSpc>
-                <a:spcPct val="100000"/>
-              </a:lnSpc>
-              <a:spcBef>
-                <a:spcPts val="0"/>
-              </a:spcBef>
-              <a:spcAft>
-                <a:spcPts val="0"/>
-              </a:spcAft>
-              <a:buClrTx/>
-              <a:buSzTx/>
-              <a:buFontTx/>
-              <a:buNone/>
-              <a:tabLst/>
-              <a:defRPr/>
-            </a:pPr>
-            <a:r>
-              <a:rPr lang="en-US" sz="1200" dirty="0">
-                <a:solidFill>
-                  <a:srgbClr val="FFFFFF"/>
-                </a:solidFill>
-                <a:latin typeface="Calibri" pitchFamily="34" charset="0"/>
-                <a:ea typeface="Calibri" pitchFamily="34" charset="-122"/>
-                <a:cs typeface="Calibri" pitchFamily="34" charset="-120"/>
-              </a:rPr>
-              <a:t>2. Design clarity, capability and commitment to establish expectations.</a:t>
-            </a:r>
-            <a:endParaRPr lang="en-US" sz="1200" dirty="0"/>
-          </a:p>
-          <a:p>
-            <a:r>
-              <a:rPr lang="en-US" dirty="0"/>
-              <a:t>
-</a:t>
-            </a:r>
-          </a:p>
-          <a:p>
-            <a:r>
-              <a:rPr dirty="0"/>
+            <a:r>
+              <a:t>SECTION 1 · AWARENESS — WHAT</a:t>
+            </a:r>
+          </a:p>
+          <a:p>
+            <a:r>
+              <a:t>What is Establishing Performance Expectations?</a:t>
+            </a:r>
+          </a:p>
+          <a:p>
+            <a:r>
+              <a:t>Naming the distinction between setting and establishing expectations — and the two mechanisms that close the gap between a delivery goal and genuine ownership.</a:t>
+            </a:r>
+          </a:p>
+          <a:p/>
+          <a:p>
+            <a:r>
+              <a:t>Section learning outcomes:</a:t>
+            </a:r>
+          </a:p>
+          <a:p>
+            <a:r>
+              <a:t>1. Distinguish setting expectations from establishing shared ownership.</a:t>
+            </a:r>
+          </a:p>
+          <a:p>
+            <a:r>
+              <a:t>2. Identify human commitments and organisational conditions that require agreement.</a:t>
+            </a:r>
+          </a:p>
+          <a:p/>
+          <a:p/>
+          <a:p>
+            <a:r>
               <a:t>Facilitator script (full wording): </a:t>
             </a:r>
-            <a:endParaRPr lang="en-ZA" dirty="0"/>
-          </a:p>
-          <a:p>
-            <a:r>
-              <a:rPr dirty="0"/>
+          </a:p>
+          <a:p>
+            <a:r>
               <a:t>The performance management and accountability frameworks and structures have been established. </a:t>
             </a:r>
-            <a:endParaRPr lang="en-ZA" dirty="0"/>
-          </a:p>
-          <a:p>
-            <a:r>
-              <a:rPr dirty="0"/>
+          </a:p>
+          <a:p>
+            <a:r>
               <a:t>The delivery goals have been defined. The targets have been set.</a:t>
             </a:r>
           </a:p>
           <a:p>
             <a:r>
-              <a:rPr dirty="0"/>
               <a:t>Here is a question worth sitting with for a moment: If you distributed the scorecard to your team right now, without conversation, without context, without dialogue, how many of them would feel genuinely ready to own these targets?</a:t>
             </a:r>
           </a:p>
-          <a:p>
-            <a:endParaRPr lang="en-ZA" dirty="0"/>
-          </a:p>
-          <a:p>
-            <a:r>
-              <a:rPr dirty="0"/>
+          <a:p/>
+          <a:p>
+            <a:r>
               <a:t>Agreeing with the targets and understanding them intellectually is one thing. </a:t>
             </a:r>
-            <a:endParaRPr lang="en-ZA" dirty="0"/>
-          </a:p>
-          <a:p>
-            <a:r>
-              <a:rPr dirty="0"/>
+          </a:p>
+          <a:p>
+            <a:r>
               <a:t>Owning them, with confidence, commitment, and a clear sense of personal accountability, is the test.</a:t>
             </a:r>
           </a:p>
-          <a:p>
-            <a:endParaRPr lang="en-ZA" dirty="0"/>
-          </a:p>
-          <a:p>
-            <a:r>
-              <a:rPr dirty="0"/>
+          <a:p/>
+          <a:p>
+            <a:r>
               <a:t>Establishing performance expectations addresses the gap between a well-designed performance management system and genuine ownership. </a:t>
             </a:r>
-            <a:endParaRPr lang="en-ZA" dirty="0"/>
-          </a:p>
-          <a:p>
-            <a:r>
-              <a:rPr dirty="0"/>
+          </a:p>
+          <a:p>
+            <a:r>
               <a:t>The difference between a delivery goal that gets pursued with energy and one that gets managed defensively comes down to whether the person holding the target genuinely believes they can deliver it, and whether they trust that their leader will support them in doing so. </a:t>
             </a:r>
-            <a:endParaRPr lang="en-ZA" dirty="0"/>
-          </a:p>
-          <a:p>
-            <a:r>
-              <a:rPr dirty="0"/>
+          </a:p>
+          <a:p>
+            <a:r>
               <a:t>The number on the page almost never decides it.</a:t>
             </a:r>
           </a:p>
@@ -4083,258 +3722,203 @@
           <a:lstStyle/>
           <a:p>
             <a:r>
-              <a:rPr lang="en-US" dirty="0"/>
-              <a:t>1.1 — SETTING VS ESTABLISHING EXPECTATIONS (The defining distinction)
-</a:t>
-            </a:r>
-            <a:r>
-              <a:rPr lang="en-US" b="1" dirty="0"/>
+              <a:t>1.1 — SETTING VS ESTABLISHING EXPECTATIONS (The defining distinction)</a:t>
+            </a:r>
+          </a:p>
+          <a:p/>
+          <a:p>
+            <a:r>
               <a:t>Content:</a:t>
             </a:r>
-            <a:r>
-              <a:rPr lang="en-US" dirty="0"/>
-              <a:t>
-The difference between setting expectations and establishing expectations is subtle in language and profound in execution impact. </a:t>
-            </a:r>
-          </a:p>
-          <a:p>
-            <a:r>
-              <a:rPr lang="en-US" dirty="0"/>
-              <a:t>It determines whether a performance target becomes an instruction that people comply with or a commitment that people own.
-Execution begins when the people responsible for those goals internalise the expectation and accept ownership of the result.
-</a:t>
-            </a:r>
-          </a:p>
-          <a:p>
-            <a:r>
-              <a:rPr b="1" dirty="0"/>
+          </a:p>
+          <a:p>
+            <a:r>
+              <a:t>The difference between setting expectations and establishing expectations is subtle in language and profound in execution impact. </a:t>
+            </a:r>
+          </a:p>
+          <a:p>
+            <a:r>
+              <a:t>It determines whether a performance target becomes an instruction that people comply with or a commitment that people own.</a:t>
+            </a:r>
+          </a:p>
+          <a:p>
+            <a:r>
+              <a:t>Execution begins when the people responsible for those goals internalise the expectation and accept ownership of the result.</a:t>
+            </a:r>
+          </a:p>
+          <a:p/>
+          <a:p>
+            <a:r>
+              <a:t>Both performance views:</a:t>
+            </a:r>
+          </a:p>
+          <a:p>
+            <a:r>
+              <a:t>Unit 6 has already translated enterprise outcomes into functional contributions, team and individual commitments, and the enabling conditions captured in ESRG. Unit 7 establishes agreement around that design. An assigned KPI or OKR is a proposed expectation until the contributor and relevant enabling owners have confirmed what delivery requires.</a:t>
+            </a:r>
+          </a:p>
+          <a:p>
+            <a:r>
+              <a:t>Human expectations describe the result, contribution, standard, timing and behaviours for which people will take responsibility. Organisational expectations specify the Environment, Systems, Resources and Governance that the organisation will provide or resolve. Both must be explicitly agreed.</a:t>
+            </a:r>
+          </a:p>
+          <a:p>
+            <a:r>
+              <a:t>Enabling conditions: when expectations are set, they are assumed to be in place; when expectations are established, they are agreed with the owners of the Environment, Systems, Resources and Governance.</a:t>
+            </a:r>
+          </a:p>
+          <a:p/>
+          <a:p>
+            <a:r>
               <a:t>Setting expectations in practice: </a:t>
             </a:r>
-            <a:endParaRPr lang="en-ZA" b="1" dirty="0"/>
-          </a:p>
-          <a:p>
-            <a:r>
-              <a:rPr dirty="0"/>
+          </a:p>
+          <a:p>
+            <a:r>
               <a:t>Setting expectations is typically a top-down declaration. </a:t>
             </a:r>
-            <a:endParaRPr lang="en-ZA" dirty="0"/>
-          </a:p>
-          <a:p>
-            <a:r>
-              <a:rPr dirty="0"/>
+          </a:p>
+          <a:p>
+            <a:r>
               <a:t>A leader defines the target, communicates the requirement, and assigns responsibility. </a:t>
             </a:r>
-            <a:endParaRPr lang="en-ZA" dirty="0"/>
-          </a:p>
-          <a:p>
-            <a:r>
-              <a:rPr dirty="0"/>
+          </a:p>
+          <a:p>
+            <a:r>
               <a:t>The process focuses primarily on clarity of instruction and leaves the readiness of the person expected to deliver untested. </a:t>
             </a:r>
-            <a:endParaRPr lang="en-ZA" dirty="0"/>
-          </a:p>
-          <a:p>
-            <a:r>
-              <a:rPr dirty="0"/>
+          </a:p>
+          <a:p>
+            <a:r>
               <a:t>The emphasis is on communicating the standard.</a:t>
             </a:r>
           </a:p>
-          <a:p>
-            <a:endParaRPr lang="en-ZA" dirty="0"/>
-          </a:p>
-          <a:p>
-            <a:r>
-              <a:rPr dirty="0"/>
+          <a:p/>
+          <a:p>
+            <a:r>
               <a:t>Typical characteristics of setting: </a:t>
             </a:r>
-            <a:endParaRPr lang="en-ZA" dirty="0"/>
-          </a:p>
-          <a:p>
-            <a:r>
-              <a:rPr dirty="0"/>
+          </a:p>
+          <a:p>
+            <a:r>
               <a:t>targets communicated through scorecards, emails, or performance reviews; limited dialogue about feasibility or constraints; responsibility assigned based on role description or reporting structure; an assumption that understanding automatically translates into commitment.</a:t>
             </a:r>
           </a:p>
-          <a:p>
-            <a:endParaRPr lang="en-ZA" dirty="0"/>
-          </a:p>
-          <a:p>
-            <a:r>
-              <a:rPr dirty="0"/>
+          <a:p/>
+          <a:p>
+            <a:r>
               <a:t>In this mode, expectations function as instructions. People may understand the goal and still carry unspoken concerns:</a:t>
             </a:r>
           </a:p>
           <a:p>
             <a:r>
-              <a:rPr dirty="0"/>
               <a:t>- Do I have the resources required?</a:t>
             </a:r>
           </a:p>
           <a:p>
             <a:r>
-              <a:rPr dirty="0"/>
               <a:t>- Do other functions understand their role in this result?</a:t>
             </a:r>
           </a:p>
           <a:p>
             <a:r>
-              <a:rPr dirty="0"/>
               <a:t>- Is this priority stable or likely to change next month?</a:t>
             </a:r>
           </a:p>
           <a:p>
             <a:r>
-              <a:rPr dirty="0"/>
               <a:t>- What trade-offs should I make to deliver this target?</a:t>
             </a:r>
           </a:p>
-          <a:p>
-            <a:endParaRPr lang="en-ZA" dirty="0"/>
-          </a:p>
-          <a:p>
-            <a:r>
-              <a:rPr dirty="0"/>
+          <a:p/>
+          <a:p>
+            <a:r>
               <a:t>When these questions remain unaddressed, individuals often move forward with defensive ownership: they monitor the delivery output carefully and avoid full accountability for the outcome. Execution in this environment tends to produce cautious behaviour, escalation of risks upward, protective reporting, and slower decision cycles.</a:t>
             </a:r>
           </a:p>
-          <a:p>
-            <a:endParaRPr dirty="0"/>
-          </a:p>
-          <a:p>
-            <a:r>
-              <a:rPr b="1" dirty="0"/>
+          <a:p/>
+          <a:p>
+            <a:r>
               <a:t>Establishing expectations in practice: </a:t>
             </a:r>
-            <a:endParaRPr lang="en-ZA" b="1" dirty="0"/>
-          </a:p>
-          <a:p>
-            <a:r>
-              <a:rPr dirty="0"/>
+          </a:p>
+          <a:p>
+            <a:r>
               <a:t>The leader still defines the result required, and the process goes further by ensuring that the person responsible fully understands, accepts, and commits to delivering the outcome. </a:t>
             </a:r>
-            <a:endParaRPr lang="en-ZA" dirty="0"/>
-          </a:p>
-          <a:p>
-            <a:r>
-              <a:rPr dirty="0"/>
+          </a:p>
+          <a:p>
+            <a:r>
               <a:t>The emphasis shifts from instruction to mutual readiness for execution.</a:t>
             </a:r>
           </a:p>
           <a:p>
             <a:r>
-              <a:rPr dirty="0"/>
-              <a:t>Establishing expectations therefore includes several additional leadership </a:t>
-            </a:r>
-            <a:r>
-              <a:rPr dirty="0" err="1"/>
-              <a:t>behaviours</a:t>
-            </a:r>
-            <a:r>
-              <a:rPr dirty="0"/>
-              <a:t>: clarifying why the result matters; testing whether the expectation is feasible; identifying dependencies across the expectations chain; surfacing constraints before execution begins; securing emotional commitment to the target.</a:t>
-            </a:r>
-          </a:p>
-          <a:p>
-            <a:endParaRPr dirty="0"/>
-          </a:p>
-          <a:p>
-            <a:r>
-              <a:rPr b="1" dirty="0"/>
+              <a:t>Establishing expectations therefore includes several additional leadership behaviours: clarifying why the result matters; testing whether the expectation is feasible; identifying dependencies across the expectations chain; surfacing constraints before execution begins; securing emotional commitment to the target.</a:t>
+            </a:r>
+          </a:p>
+          <a:p/>
+          <a:p>
+            <a:r>
               <a:t>Why this distinction matters in strategy execution: </a:t>
             </a:r>
-            <a:endParaRPr lang="en-ZA" b="1" dirty="0"/>
-          </a:p>
-          <a:p>
-            <a:r>
-              <a:rPr dirty="0"/>
+          </a:p>
+          <a:p>
+            <a:r>
               <a:t>Most organisations invest heavily in designing performance systems: balanced scorecards, OKRs, dashboards, and KPIs. </a:t>
             </a:r>
-            <a:endParaRPr lang="en-ZA" dirty="0"/>
-          </a:p>
-          <a:p>
-            <a:r>
-              <a:rPr dirty="0"/>
+          </a:p>
+          <a:p>
+            <a:r>
               <a:t>Execution success depends on whether the people responsible for those measures genuinely own the outcome. </a:t>
             </a:r>
-            <a:endParaRPr lang="en-ZA" dirty="0"/>
-          </a:p>
-          <a:p>
-            <a:r>
-              <a:rPr dirty="0"/>
+          </a:p>
+          <a:p>
+            <a:r>
               <a:t>The sophistication of the measurement system alone rarely secures it.</a:t>
             </a:r>
           </a:p>
-          <a:p>
-            <a:endParaRPr lang="en-ZA" dirty="0"/>
-          </a:p>
-          <a:p>
-            <a:r>
-              <a:rPr dirty="0"/>
+          <a:p/>
+          <a:p>
+            <a:r>
               <a:t>When expectations are merely set: metrics are monitored; performance is managed; accountability remains conditional.</a:t>
             </a:r>
           </a:p>
-          <a:p>
-            <a:endParaRPr lang="en-ZA" dirty="0"/>
-          </a:p>
-          <a:p>
-            <a:r>
-              <a:rPr dirty="0"/>
-              <a:t>When expectations are established: ownership is </a:t>
-            </a:r>
-            <a:r>
-              <a:rPr dirty="0" err="1"/>
-              <a:t>internalised</a:t>
-            </a:r>
-            <a:r>
-              <a:rPr dirty="0"/>
-              <a:t>; accountability becomes personal; performance improves through proactive effort.</a:t>
-            </a:r>
-          </a:p>
-          <a:p>
-            <a:endParaRPr lang="en-ZA" dirty="0"/>
-          </a:p>
-          <a:p>
-            <a:r>
-              <a:rPr dirty="0"/>
+          <a:p/>
+          <a:p>
+            <a:r>
+              <a:t>When expectations are established: ownership is internalised; accountability becomes personal; performance improves through proactive effort.</a:t>
+            </a:r>
+          </a:p>
+          <a:p/>
+          <a:p>
+            <a:r>
               <a:t>The technical architecture of performance management provides measurement visibility. </a:t>
             </a:r>
-            <a:endParaRPr lang="en-ZA" dirty="0"/>
-          </a:p>
-          <a:p>
-            <a:r>
-              <a:rPr dirty="0"/>
+          </a:p>
+          <a:p>
+            <a:r>
               <a:t>The process of establishing expectations provides behavioural commitment. </a:t>
             </a:r>
-            <a:endParaRPr lang="en-ZA" dirty="0"/>
-          </a:p>
-          <a:p>
-            <a:r>
-              <a:rPr dirty="0"/>
+          </a:p>
+          <a:p>
+            <a:r>
               <a:t>Both are necessary. Without the second, the first rarely produces sustained execution results.</a:t>
             </a:r>
           </a:p>
-          <a:p>
-            <a:endParaRPr lang="en-ZA" dirty="0"/>
-          </a:p>
-          <a:p>
-            <a:r>
-              <a:rPr dirty="0"/>
+          <a:p/>
+          <a:p>
+            <a:r>
               <a:t>The transition from setting to establishing expectations is where performance management becomes execution leadership.</a:t>
             </a:r>
           </a:p>
-          <a:p>
-            <a:endParaRPr dirty="0"/>
-          </a:p>
-          <a:p>
-            <a:r>
-              <a:rPr dirty="0"/>
+          <a:p/>
+          <a:p>
+            <a:r>
               <a:t>The same demand delivered as a command and as a request produces materially different results from the same people. Tone, humility and the manner of the ask often decide the outcome. </a:t>
             </a:r>
-            <a:endParaRPr lang="en-ZA" dirty="0"/>
-          </a:p>
-          <a:p>
-            <a:endParaRPr dirty="0"/>
-          </a:p>
+          </a:p>
+          <a:p/>
         </p:txBody>
       </p:sp>
       <p:sp>
@@ -4418,314 +4002,465 @@
           <a:lstStyle/>
           <a:p>
             <a:r>
-              <a:rPr lang="en-US" dirty="0"/>
-              <a:t>1.2 — THE THREE CONDITIONS OF ESTABLISHED EXPECTATIONS (Clarity · Capability · Commitment)
-FACILITATOR GUIDANCE
-Most leaders overestimate how much Clarity they have provided and underestimate how little Commitment they have secured. </a:t>
-            </a:r>
-          </a:p>
-          <a:p>
-            <a:r>
-              <a:rPr lang="en-US" dirty="0"/>
+              <a:t>1.2 — THE THREE CONDITIONS OF ESTABLISHED EXPECTATIONS (Clarity · Capability · Commitment)</a:t>
+            </a:r>
+          </a:p>
+          <a:p/>
+          <a:p>
+            <a:r>
+              <a:t>FACILITATOR GUIDANCE</a:t>
+            </a:r>
+          </a:p>
+          <a:p>
+            <a:r>
+              <a:t>Most leaders overestimate how much Clarity they have provided and underestimate how little Commitment they have secured. </a:t>
+            </a:r>
+          </a:p>
+          <a:p>
+            <a:r>
               <a:t>The conversation usually sounds complete to the leader and feels incomplete to the team member. </a:t>
             </a:r>
           </a:p>
-          <a:p>
-            <a:endParaRPr lang="en-US" dirty="0"/>
-          </a:p>
-          <a:p>
-            <a:r>
-              <a:rPr lang="en-US" dirty="0"/>
-              <a:t>Ask: “After your last expectations conversation, which of the three conditions did you explicitly verify? Clarity — probably. Capability — sometimes. Commitment — almost never.”
-</a:t>
-            </a:r>
-            <a:r>
-              <a:rPr lang="en-US" b="1" dirty="0"/>
+          <a:p/>
+          <a:p>
+            <a:r>
+              <a:t>Ask: “After your last expectations conversation, which of the three conditions did you explicitly verify? Clarity — probably. Capability — sometimes. Commitment — almost never.”</a:t>
+            </a:r>
+          </a:p>
+          <a:p/>
+          <a:p>
+            <a:r>
               <a:t>Content:</a:t>
             </a:r>
-            <a:r>
-              <a:rPr lang="en-US" dirty="0"/>
-              <a:t>
-When expectations are properly established, three conditions are simultaneously present. </a:t>
-            </a:r>
-          </a:p>
-          <a:p>
-            <a:r>
-              <a:rPr lang="en-US" dirty="0"/>
-              <a:t>All three must be confirmed before execution begins. A KPI becomes a personal leadership promise only when all three are in place.
-</a:t>
-            </a:r>
-          </a:p>
-          <a:p>
-            <a:r>
-              <a:rPr lang="en-US" b="1" dirty="0"/>
+          </a:p>
+          <a:p>
+            <a:r>
+              <a:t>Establishing performance expectations is a leadership process through which strategic contributions become understood, achievable and consciously owned.</a:t>
+            </a:r>
+          </a:p>
+          <a:p>
+            <a:r>
+              <a:t>In Unit 6, the S2R® Contribution Map™ established how enterprise results depend on the contributions of business functions, teams and individuals. It also identified the organisational conditions required to support those contributions.</a:t>
+            </a:r>
+          </a:p>
+          <a:p>
+            <a:r>
+              <a:t>The next responsibility is to ensure that these expectations are genuinely established with everyone involved in delivering the results.</a:t>
+            </a:r>
+          </a:p>
+          <a:p>
+            <a:r>
+              <a:t>Three conditions must be addressed: Clarity, Capability and Commitment. Together, they establish accountability across two interconnected operating systems:</a:t>
+            </a:r>
+          </a:p>
+          <a:p>
+            <a:r>
+              <a:t>- Human Operating System: What individuals and teams must deliver, how they must perform and the behaviours expected of them.</a:t>
+            </a:r>
+          </a:p>
+          <a:p>
+            <a:r>
+              <a:t>- Organisational Operating System (ESRG): The environment, systems, resources and governance arrangements that must support delivery.</a:t>
+            </a:r>
+          </a:p>
+          <a:p>
+            <a:r>
+              <a:t>Each condition answers a fundamental leadership question.</a:t>
+            </a:r>
+          </a:p>
+          <a:p/>
+          <a:p>
+            <a:r>
               <a:t>Condition 1</a:t>
             </a:r>
-            <a:r>
-              <a:rPr lang="en-US" dirty="0"/>
-              <a:t>
-</a:t>
-            </a:r>
-            <a:r>
-              <a:rPr lang="en-US" b="1" dirty="0"/>
-              <a:t>Clarity — </a:t>
-            </a:r>
-            <a:r>
-              <a:rPr lang="en-US" dirty="0"/>
-              <a:t>The individual understands exactly what success looks like
-Clarity means understanding the full picture of the expected outcome: what must be delivered, by when, at what standard, and how success will be recognised. Most expectation conversations stop at the number. </a:t>
-            </a:r>
-          </a:p>
-          <a:p>
-            <a:r>
-              <a:rPr lang="en-US" dirty="0"/>
-              <a:t>Establishing expectations requires confirming that both parties share the same picture of the result.</a:t>
-            </a:r>
-          </a:p>
-          <a:p>
-            <a:pPr marL="0" marR="0" lvl="0" indent="0" algn="l" defTabSz="914400" rtl="0" eaLnBrk="1" fontAlgn="auto" latinLnBrk="0" hangingPunct="1">
-              <a:lnSpc>
-                <a:spcPct val="100000"/>
-              </a:lnSpc>
-              <a:spcBef>
-                <a:spcPts val="0"/>
-              </a:spcBef>
-              <a:spcAft>
-                <a:spcPts val="0"/>
-              </a:spcAft>
-              <a:buClrTx/>
-              <a:buSzTx/>
-              <a:buFontTx/>
-              <a:buNone/>
-              <a:tabLst/>
-              <a:defRPr/>
-            </a:pPr>
-            <a:r>
-              <a:rPr lang="en-GB" dirty="0"/>
+          </a:p>
+          <a:p>
+            <a:r>
+              <a:t>Clarity — Does everyone understand what is expected, why it matters and what successful delivery requires?</a:t>
+            </a:r>
+          </a:p>
+          <a:p>
+            <a:r>
+              <a:t>Clarity establishes a shared understanding of the expected contribution.</a:t>
+            </a:r>
+          </a:p>
+          <a:p>
+            <a:r>
+              <a:t>A performance expectation must connect directly to the enterprise result it supports. Individuals and teams need to understand the contribution they are responsible for, the standard of performance required and how success will be demonstrated.</a:t>
+            </a:r>
+          </a:p>
+          <a:p>
+            <a:r>
+              <a:t>Clarity must also extend to the organisation’s responsibilities. Leaders need to establish what support, decisions and enabling conditions must be provided for the contribution to be delivered.</a:t>
+            </a:r>
+          </a:p>
+          <a:p>
+            <a:r>
+              <a:t>Clarity in the Human Operating System</a:t>
+            </a:r>
+          </a:p>
+          <a:p>
+            <a:r>
+              <a:t>The leader and individual establish a shared understanding of:</a:t>
+            </a:r>
+          </a:p>
+          <a:p>
+            <a:r>
+              <a:t>- Strategic contribution: Which enterprise objective or result does this work support?</a:t>
+            </a:r>
+          </a:p>
+          <a:p>
+            <a:r>
+              <a:t>- Performance expectations: What KPI, OKR or other agreed deliverable defines success?</a:t>
+            </a:r>
+          </a:p>
+          <a:p>
+            <a:r>
+              <a:t>- Performance standard: What level of quality, quantity, timeliness or consistency is required?</a:t>
+            </a:r>
+          </a:p>
+          <a:p>
+            <a:r>
+              <a:t>- Behavioural expectations: What observable behaviours and ways of working are necessary?</a:t>
+            </a:r>
+          </a:p>
+          <a:p>
+            <a:r>
+              <a:t>- Evidence: How will successful performance be demonstrated and assessed?</a:t>
+            </a:r>
+          </a:p>
+          <a:p>
+            <a:r>
+              <a:t>Clarity in the Organisational Operating System (ESRG)</a:t>
+            </a:r>
+          </a:p>
+          <a:p>
+            <a:r>
+              <a:t>The leader establishes what the organisation must provide:</a:t>
+            </a:r>
+          </a:p>
+          <a:p>
+            <a:r>
+              <a:t>- Environment: What working conditions, relationships or cultural practices must support delivery?</a:t>
+            </a:r>
+          </a:p>
+          <a:p>
+            <a:r>
+              <a:t>- Systems: What processes, technology, information and coordination mechanisms must function?</a:t>
+            </a:r>
+          </a:p>
+          <a:p>
+            <a:r>
+              <a:t>- Resources: What people, skills, time, funding or equipment must be available?</a:t>
+            </a:r>
+          </a:p>
+          <a:p>
+            <a:r>
+              <a:t>- Governance: What decisions, authority, approvals and escalation arrangements must be established?</a:t>
+            </a:r>
+          </a:p>
+          <a:p>
+            <a:r>
+              <a:t>Clarity is established when the parties share the same understanding of both the expected contribution and the conditions required to deliver it.</a:t>
+            </a:r>
+          </a:p>
+          <a:p>
+            <a:r>
+              <a:t>Facilitation test: “Ask someone on your team to describe what success looks like for their key result. If the description differs from yours, clarity has not yet been established.”</a:t>
+            </a:r>
+          </a:p>
+          <a:p>
+            <a:r>
               <a:t>Many operational failures happen because people in authority believe execution needs their presence when it needs their clarity. Authority travels with a clear instruction.</a:t>
             </a:r>
           </a:p>
-          <a:p>
-            <a:endParaRPr lang="en-US" dirty="0"/>
-          </a:p>
-          <a:p>
-            <a:r>
-              <a:rPr lang="en-US" dirty="0"/>
-              <a:t>Facilitation test: “Ask someone on your team to describe what success looks like for their key result. If the description differs from yours, clarity has not yet been established.”
-</a:t>
-            </a:r>
-          </a:p>
-          <a:p>
-            <a:r>
-              <a:rPr lang="en-US" b="1" dirty="0"/>
+          <a:p/>
+          <a:p>
+            <a:r>
               <a:t>Condition 2</a:t>
             </a:r>
-            <a:r>
-              <a:rPr lang="en-US" dirty="0"/>
-              <a:t>
-</a:t>
-            </a:r>
-            <a:r>
-              <a:rPr lang="en-US" b="1" dirty="0"/>
-              <a:t>Capability</a:t>
-            </a:r>
-            <a:r>
-              <a:rPr lang="en-US" dirty="0"/>
-              <a:t> — The system can realistically support delivery
-Capability in this context refers to the individual’s skill and to the system surrounding them. </a:t>
-            </a:r>
-          </a:p>
-          <a:p>
-            <a:r>
-              <a:rPr lang="en-US" dirty="0"/>
-              <a:t>Can the organisation actually support delivery of this expectation? Are the resources, decisions, cross-functional dependencies, and coordination mechanisms in place? </a:t>
-            </a:r>
-          </a:p>
-          <a:p>
-            <a:r>
-              <a:rPr lang="en-US" dirty="0"/>
-              <a:t>A person may fully understand and deeply want to own a target that the current system cannot deliver. </a:t>
-            </a:r>
-          </a:p>
-          <a:p>
-            <a:r>
-              <a:rPr lang="en-US" dirty="0"/>
-              <a:t>Establishing expectations surfaces this before execution begins.</a:t>
-            </a:r>
-          </a:p>
-          <a:p>
-            <a:pPr marL="0" marR="0" lvl="0" indent="0" algn="l" defTabSz="914400" rtl="0" eaLnBrk="1" fontAlgn="auto" latinLnBrk="0" hangingPunct="1">
-              <a:lnSpc>
-                <a:spcPct val="100000"/>
-              </a:lnSpc>
-              <a:spcBef>
-                <a:spcPts val="0"/>
-              </a:spcBef>
-              <a:spcAft>
-                <a:spcPts val="0"/>
-              </a:spcAft>
-              <a:buClrTx/>
-              <a:buSzTx/>
-              <a:buFontTx/>
-              <a:buNone/>
-              <a:tabLst/>
-              <a:defRPr/>
-            </a:pPr>
-            <a:r>
-              <a:rPr lang="en-GB" dirty="0"/>
+          </a:p>
+          <a:p>
+            <a:r>
+              <a:t>Capability — Can the people and the organisation realistically deliver what is expected?</a:t>
+            </a:r>
+          </a:p>
+          <a:p>
+            <a:r>
+              <a:t>Capability establishes whether the expectation is achievable under the conditions in which performance must occur.</a:t>
+            </a:r>
+          </a:p>
+          <a:p>
+            <a:r>
+              <a:t>An individual may understand an expectation perfectly and be willing to deliver it, yet lack the skills, capacity, resources or organisational support required. This makes capability a shared leadership responsibility.</a:t>
+            </a:r>
+          </a:p>
+          <a:p>
+            <a:r>
+              <a:t>Capability in the Human Operating System</a:t>
+            </a:r>
+          </a:p>
+          <a:p>
+            <a:r>
+              <a:t>The leader assesses whether the individual or team has:</a:t>
+            </a:r>
+          </a:p>
+          <a:p>
+            <a:r>
+              <a:t>- Competence: The knowledge and skills required to perform the work.</a:t>
+            </a:r>
+          </a:p>
+          <a:p>
+            <a:r>
+              <a:t>- Capacity: Sufficient time and workload capacity to meet the expectation.</a:t>
+            </a:r>
+          </a:p>
+          <a:p>
+            <a:r>
+              <a:t>- Readiness: The confidence, experience and practical preparation needed to begin.</a:t>
+            </a:r>
+          </a:p>
+          <a:p>
+            <a:r>
+              <a:t>- Coordination: Access to the colleagues and teams whose contributions affect the result.</a:t>
+            </a:r>
+          </a:p>
+          <a:p>
+            <a:r>
+              <a:t>Where gaps exist, the leader and individual agree on appropriate development, support or adjustments.</a:t>
+            </a:r>
+          </a:p>
+          <a:p>
+            <a:r>
+              <a:t>Capability in the Organisational Operating System (ESRG)</a:t>
+            </a:r>
+          </a:p>
+          <a:p>
+            <a:r>
+              <a:t>The leader examines whether the organisation has established the conditions necessary for delivery.</a:t>
+            </a:r>
+          </a:p>
+          <a:p>
+            <a:r>
+              <a:t>ESRG domainCapability question</a:t>
+            </a:r>
+          </a:p>
+          <a:p>
+            <a:r>
+              <a:t>Environment: Do working conditions and relationships support the required performance?</a:t>
+            </a:r>
+          </a:p>
+          <a:p>
+            <a:r>
+              <a:t>Systems: Can existing processes, technology and information support consistent delivery?</a:t>
+            </a:r>
+          </a:p>
+          <a:p>
+            <a:r>
+              <a:t>Resources: Are the required people, funding, equipment and time available?</a:t>
+            </a:r>
+          </a:p>
+          <a:p>
+            <a:r>
+              <a:t>Governance: Are decisions, authority and escalation mechanisms sufficiently clear and responsive?</a:t>
+            </a:r>
+          </a:p>
+          <a:p>
+            <a:r>
+              <a:t>An identified gap must lead to an agreed response. For every significant constraint, leaders establish:</a:t>
+            </a:r>
+          </a:p>
+          <a:p>
+            <a:r>
+              <a:t>- What must be resolved.</a:t>
+            </a:r>
+          </a:p>
+          <a:p>
+            <a:r>
+              <a:t>- Who is accountable for resolving it.</a:t>
+            </a:r>
+          </a:p>
+          <a:p>
+            <a:r>
+              <a:t>- When the resolution is required.</a:t>
+            </a:r>
+          </a:p>
+          <a:p>
+            <a:r>
+              <a:t>- What interim arrangements will apply if the constraint remains unresolved.</a:t>
+            </a:r>
+          </a:p>
+          <a:p>
+            <a:r>
+              <a:t>Capability is established when the required human abilities and organisational conditions have been confirmed, or when identified gaps have accountable resolution arrangements.</a:t>
+            </a:r>
+          </a:p>
+          <a:p>
+            <a:r>
               <a:t>Strategy is weakened when leaders become so committed to movement that they ignore capability gaps. A disciplined readiness pause can prevent an expensive failure later.</a:t>
             </a:r>
           </a:p>
-          <a:p>
-            <a:endParaRPr lang="en-US" dirty="0"/>
-          </a:p>
-          <a:p>
-            <a:r>
-              <a:rPr lang="en-US" b="1" dirty="0"/>
+          <a:p/>
+          <a:p>
+            <a:r>
               <a:t>Condition 3</a:t>
             </a:r>
-            <a:r>
-              <a:rPr lang="en-US" dirty="0"/>
-              <a:t>
-</a:t>
-            </a:r>
-            <a:r>
-              <a:rPr lang="en-US" b="1" dirty="0"/>
-              <a:t>Commitment </a:t>
-            </a:r>
-            <a:r>
-              <a:rPr lang="en-US" dirty="0"/>
-              <a:t>— The person consciously accepts ownership of the outcome
-Commitment is the moment the expectation crosses from instruction to promise. </a:t>
-            </a:r>
-          </a:p>
-          <a:p>
-            <a:r>
-              <a:rPr lang="en-US" dirty="0"/>
-              <a:t>The individual accepts personal responsibility for ensuring the outcome is delivered. </a:t>
-            </a:r>
-          </a:p>
-          <a:p>
-            <a:r>
-              <a:rPr lang="en-US" dirty="0"/>
-              <a:t>This cannot be assumed from nodding agreement or email confirmation. It must be actively tested through dialogue. </a:t>
-            </a:r>
-          </a:p>
-          <a:p>
-            <a:endParaRPr lang="en-US" dirty="0"/>
-          </a:p>
-          <a:p>
-            <a:r>
-              <a:rPr lang="en-US" dirty="0"/>
-              <a:t>The Alignment Dialogue is the mechanism designed to confirm this transition has occurred.
-The Alignment Dialogue asks: “On a scale of 1–10, how aligned are you with the expectation for you to deliver this outcome?” </a:t>
-            </a:r>
-          </a:p>
-          <a:p>
-            <a:r>
-              <a:rPr lang="en-US" dirty="0"/>
-              <a:t>A score below 9 means Commitment is not yet established.
-</a:t>
-            </a:r>
-          </a:p>
-          <a:p>
-            <a:pPr marL="0" marR="0" lvl="0" indent="0" algn="l" defTabSz="914400" rtl="0" eaLnBrk="1" fontAlgn="auto" latinLnBrk="0" hangingPunct="1">
-              <a:lnSpc>
-                <a:spcPct val="100000"/>
-              </a:lnSpc>
-              <a:spcBef>
-                <a:spcPts val="0"/>
-              </a:spcBef>
-              <a:spcAft>
-                <a:spcPts val="0"/>
-              </a:spcAft>
-              <a:buClrTx/>
-              <a:buSzTx/>
-              <a:buFontTx/>
-              <a:buNone/>
-              <a:tabLst/>
-              <a:defRPr/>
-            </a:pPr>
-            <a:r>
-              <a:rPr lang="en-GB" dirty="0"/>
+          </a:p>
+          <a:p>
+            <a:r>
+              <a:t>Commitment — Have the people responsible consciously accepted their respective responsibilities for delivering and enabling the result?</a:t>
+            </a:r>
+          </a:p>
+          <a:p>
+            <a:r>
+              <a:t>Commitment is the point at which a performance expectation becomes an agreed undertaking.</a:t>
+            </a:r>
+          </a:p>
+          <a:p>
+            <a:r>
+              <a:t>Understanding an expectation does not automatically create ownership. Similarly, confirming that delivery is possible does not guarantee that the people involved have accepted responsibility for making it happen. Commitment must therefore be established through dialogue.</a:t>
+            </a:r>
+          </a:p>
+          <a:p>
+            <a:r>
+              <a:t>Commitment in the Human Operating System</a:t>
+            </a:r>
+          </a:p>
+          <a:p>
+            <a:r>
+              <a:t>The individual consciously accepts responsibility for:</a:t>
+            </a:r>
+          </a:p>
+          <a:p>
+            <a:r>
+              <a:t>- Delivering the agreed contribution and performance standard.</a:t>
+            </a:r>
+          </a:p>
+          <a:p>
+            <a:r>
+              <a:t>- Demonstrating the expected behaviours.</a:t>
+            </a:r>
+          </a:p>
+          <a:p>
+            <a:r>
+              <a:t>- Monitoring progress and providing reliable performance evidence.</a:t>
+            </a:r>
+          </a:p>
+          <a:p>
+            <a:r>
+              <a:t>- Raising risks and constraints early.</a:t>
+            </a:r>
+          </a:p>
+          <a:p>
+            <a:r>
+              <a:t>- Taking corrective action within their authority.</a:t>
+            </a:r>
+          </a:p>
+          <a:p>
+            <a:r>
+              <a:t>The leader must create space for the individual to question assumptions, discuss concerns and confirm what they can realistically undertake.</a:t>
+            </a:r>
+          </a:p>
+          <a:p>
+            <a:r>
+              <a:t>Commitment in the Organisational Operating System (ESRG)</a:t>
+            </a:r>
+          </a:p>
+          <a:p>
+            <a:r>
+              <a:t>The leaders responsible for enabling delivery accept responsibility for:</a:t>
+            </a:r>
+          </a:p>
+          <a:p>
+            <a:r>
+              <a:t>- Providing agreed resources and support.</a:t>
+            </a:r>
+          </a:p>
+          <a:p>
+            <a:r>
+              <a:t>- Resolving systems and coordination constraints.</a:t>
+            </a:r>
+          </a:p>
+          <a:p>
+            <a:r>
+              <a:t>- Making decisions within agreed timeframes.</a:t>
+            </a:r>
+          </a:p>
+          <a:p>
+            <a:r>
+              <a:t>- Removing organisational barriers that threaten delivery.</a:t>
+            </a:r>
+          </a:p>
+          <a:p>
+            <a:r>
+              <a:t>- Responding when emerging conditions require intervention.</a:t>
+            </a:r>
+          </a:p>
+          <a:p>
+            <a:r>
+              <a:t>This creates mutual accountability: individuals own their performance commitments, while organisational leaders own the conditions they have undertaken to provide.</a:t>
+            </a:r>
+          </a:p>
+          <a:p>
+            <a:r>
+              <a:t>Commitment is established when the relevant parties have consciously accepted their respective responsibilities, including any agreed actions required to enable delivery.</a:t>
+            </a:r>
+          </a:p>
+          <a:p>
+            <a:r>
+              <a:t>The Alignment Dialogue asks: “On a scale of 1–10, how aligned are you with the expectation for you to deliver this outcome?” A score below 9 means Commitment is not yet established.</a:t>
+            </a:r>
+          </a:p>
+          <a:p>
+            <a:r>
               <a:t>Commitments lose strategic meaning when they are honoured only when convenient. Good intent has limited value if people cannot understand what is required of them.</a:t>
             </a:r>
           </a:p>
-          <a:p>
-            <a:r>
-              <a:rPr lang="en-US" dirty="0"/>
-              <a:t>
-</a:t>
-            </a:r>
-          </a:p>
-          <a:p>
-            <a:r>
-              <a:rPr dirty="0"/>
+          <a:p/>
+          <a:p>
+            <a:r>
+              <a:t>Key principle: Performance expectations are established when people understand their contribution, have a credible basis for delivering it and consciously accept responsibility, supported by leaders who are equally accountable for the organisational conditions required for success.</a:t>
+            </a:r>
+          </a:p>
+          <a:p/>
+          <a:p>
+            <a:r>
               <a:t>When the three conditions are met: The conversation ensures that Clarity, Capability and Commitment are present, and execution dynamics change noticeably.</a:t>
             </a:r>
           </a:p>
           <a:p>
             <a:r>
-              <a:rPr dirty="0"/>
               <a:t>- Individuals take initiative earlier.</a:t>
             </a:r>
           </a:p>
           <a:p>
             <a:r>
-              <a:rPr dirty="0"/>
               <a:t>- Risks are surfaced sooner.</a:t>
             </a:r>
           </a:p>
           <a:p>
             <a:r>
-              <a:rPr dirty="0"/>
               <a:t>- Cross-functional coordination improves.</a:t>
             </a:r>
           </a:p>
           <a:p>
             <a:r>
-              <a:rPr dirty="0"/>
               <a:t>- Energy shifts from reporting to solving.</a:t>
             </a:r>
           </a:p>
           <a:p>
             <a:r>
-              <a:rPr dirty="0"/>
               <a:t>In this environment, expectations function as shared commitments.</a:t>
             </a:r>
           </a:p>
-          <a:p>
-            <a:endParaRPr dirty="0"/>
-          </a:p>
-          <a:p>
-            <a:pPr marL="0" marR="0" lvl="0" indent="0" algn="l" defTabSz="914400" rtl="0" eaLnBrk="1" fontAlgn="auto" latinLnBrk="0" hangingPunct="1">
-              <a:lnSpc>
-                <a:spcPct val="100000"/>
-              </a:lnSpc>
-              <a:spcBef>
-                <a:spcPts val="0"/>
-              </a:spcBef>
-              <a:spcAft>
-                <a:spcPts val="0"/>
-              </a:spcAft>
-              <a:buClrTx/>
-              <a:buSzTx/>
-              <a:buFontTx/>
-              <a:buNone/>
-              <a:tabLst/>
-              <a:defRPr/>
-            </a:pPr>
-            <a:r>
-              <a:rPr lang="en-US" dirty="0"/>
+          <a:p/>
+          <a:p>
+            <a:r>
               <a:t>Which Condition Is Most Often Missing? In your current role, which of the three conditions do you most consistently confirm — and which do you most often assume?</a:t>
             </a:r>
           </a:p>
-          <a:p>
-            <a:endParaRPr lang="en-ZA" dirty="0"/>
-          </a:p>
-          <a:p>
-            <a:endParaRPr dirty="0"/>
-          </a:p>
+          <a:p/>
+          <a:p/>
         </p:txBody>
       </p:sp>
       <p:sp>
@@ -4809,113 +4544,236 @@
           <a:lstStyle/>
           <a:p>
             <a:r>
-              <a:rPr lang="en-US" dirty="0"/>
-              <a:t>1.3 — THE EXPECTATIONS CHAIN (Mapping who else influences the outcome)
-</a:t>
-            </a:r>
-            <a:r>
-              <a:rPr lang="en-US" b="1" dirty="0"/>
+              <a:t>1.3 — THE EXPECTATIONS CHAIN (Mapping who else influences the outcome)</a:t>
+            </a:r>
+          </a:p>
+          <a:p/>
+          <a:p>
+            <a:r>
               <a:t>Content:</a:t>
             </a:r>
-            <a:r>
-              <a:rPr lang="en-US" dirty="0"/>
-              <a:t>
-Very few delivery goals are achieved by a single person acting alone. </a:t>
-            </a:r>
-          </a:p>
-          <a:p>
-            <a:r>
-              <a:rPr lang="en-US" dirty="0"/>
+          </a:p>
+          <a:p>
+            <a:r>
+              <a:t>Very few delivery goals are achieved by a single person acting alone. </a:t>
+            </a:r>
+          </a:p>
+          <a:p>
+            <a:r>
               <a:t>Most results depend on a network of decisions, resources, and coordination across the organisation. </a:t>
             </a:r>
           </a:p>
           <a:p>
             <a:r>
-              <a:rPr lang="en-GB" dirty="0"/>
               <a:t>One critical aspect of establishing expectations is first understanding who else influences the outcome. </a:t>
             </a:r>
           </a:p>
           <a:p>
             <a:r>
-              <a:rPr lang="en-GB" dirty="0"/>
               <a:t>This network is known as the Expectations Chain.</a:t>
             </a:r>
-            <a:endParaRPr lang="en-US" dirty="0"/>
-          </a:p>
-          <a:p>
-            <a:r>
-              <a:rPr lang="en-US" dirty="0"/>
-              <a:t>The Expectations Chain identifies everyone whose work directly affects the delivery of a Key Result or KPI.
-Mapping the Expectations Chain is a critical step before establishing expectations with any individual. </a:t>
-            </a:r>
-          </a:p>
-          <a:p>
-            <a:r>
-              <a:rPr lang="en-US" dirty="0"/>
-              <a:t>It ensures that the KPI is not treated as an isolated personal obligation — and surfaces the dependencies that will determine whether delivery is possible.
-</a:t>
-            </a:r>
-          </a:p>
-          <a:p>
-            <a:r>
-              <a:rPr lang="en-US" dirty="0"/>
-              <a:t>There are three flows in the expectations chain:</a:t>
-            </a:r>
-          </a:p>
-          <a:p>
-            <a:r>
-              <a:rPr lang="en-US" dirty="0"/>
-              <a:t>
-</a:t>
-            </a:r>
-            <a:r>
-              <a:rPr lang="en-US" b="1" dirty="0"/>
-              <a:t>1. Upline Chain</a:t>
-            </a:r>
-            <a:r>
-              <a:rPr lang="en-US" dirty="0"/>
-              <a:t>
-Who
-Individuals the leader depends on for approval, decisions, or resources
-Examples
-Executive leadership, board members, executive sponsors, budget holders
-Key question
-Who must approve or resource this outcome for delivery to be possible?
-</a:t>
-            </a:r>
-            <a:r>
-              <a:rPr lang="en-US" b="1" dirty="0"/>
-              <a:t>2. Downline Chain</a:t>
-            </a:r>
-            <a:r>
-              <a:rPr lang="en-US" dirty="0"/>
-              <a:t>
-Who
-Individuals responsible for executing the work required to achieve the KPI
-Examples
-Direct reports, project teams, cross-functional collaborators, shared service functions
-Key question
-Who must deliver specific activities for this outcome to be achieved?
-</a:t>
-            </a:r>
-            <a:r>
-              <a:rPr lang="en-US" b="1" dirty="0"/>
-              <a:t>3. External Chain</a:t>
-            </a:r>
-            <a:r>
-              <a:rPr lang="en-US" dirty="0"/>
-              <a:t>
-Who
-External actors whose contributions influence delivery success
-Examples
-Suppliers, service partners, contractors, regulatory bodies, technology vendors
-Key question
-Which external actors influence whether this outcome can be delivered?
-</a:t>
-            </a:r>
-            <a:r>
-              <a:rPr dirty="0"/>
+          </a:p>
+          <a:p>
+            <a:r>
+              <a:t>The Expectations Chain identifies everyone whose work directly affects the delivery of a Key Result or KPI.</a:t>
+            </a:r>
+          </a:p>
+          <a:p>
+            <a:r>
+              <a:t>Mapping the Expectations Chain is a critical step before establishing expectations with any individual. </a:t>
+            </a:r>
+          </a:p>
+          <a:p>
+            <a:r>
+              <a:t>It ensures that the KPI is not treated as an isolated personal obligation — and surfaces the dependencies that will determine whether delivery is possible.</a:t>
+            </a:r>
+          </a:p>
+          <a:p/>
+          <a:p>
+            <a:r>
+              <a:t>Central question: With whom must performance expectations be established for each contribution to succeed?</a:t>
+            </a:r>
+          </a:p>
+          <a:p>
+            <a:r>
+              <a:t>The Expectations Chain uses the completed Contribution Map to identify the people with whom expectations must be explicitly established. It examines three directions:</a:t>
+            </a:r>
+          </a:p>
+          <a:p/>
+          <a:p>
+            <a:r>
+              <a:t>1. Upline</a:t>
+            </a:r>
+          </a:p>
+          <a:p>
+            <a:r>
+              <a:t>Who</a:t>
+            </a:r>
+          </a:p>
+          <a:p>
+            <a:r>
+              <a:t>Those who authorise, resource or enable delivery</a:t>
+            </a:r>
+          </a:p>
+          <a:p>
+            <a:r>
+              <a:t>What must be established</a:t>
+            </a:r>
+          </a:p>
+          <a:p>
+            <a:r>
+              <a:t>Expectations for decisions, support, approvals and removal of constraints.</a:t>
+            </a:r>
+          </a:p>
+          <a:p>
+            <a:r>
+              <a:t>Examples</a:t>
+            </a:r>
+          </a:p>
+          <a:p>
+            <a:r>
+              <a:t>Executive leadership, board members, executive sponsors, budget holders</a:t>
+            </a:r>
+          </a:p>
+          <a:p>
+            <a:r>
+              <a:t>Key question</a:t>
+            </a:r>
+          </a:p>
+          <a:p>
+            <a:r>
+              <a:t>Who must approve or resource this outcome for delivery to be possible?</a:t>
+            </a:r>
+          </a:p>
+          <a:p/>
+          <a:p>
+            <a:r>
+              <a:t>2. Downline</a:t>
+            </a:r>
+          </a:p>
+          <a:p>
+            <a:r>
+              <a:t>Who</a:t>
+            </a:r>
+          </a:p>
+          <a:p>
+            <a:r>
+              <a:t>Those who perform the work</a:t>
+            </a:r>
+          </a:p>
+          <a:p>
+            <a:r>
+              <a:t>What must be established</a:t>
+            </a:r>
+          </a:p>
+          <a:p>
+            <a:r>
+              <a:t>Expectations for results, standards, behaviours and evidence of performance.</a:t>
+            </a:r>
+          </a:p>
+          <a:p>
+            <a:r>
+              <a:t>Examples</a:t>
+            </a:r>
+          </a:p>
+          <a:p>
+            <a:r>
+              <a:t>Direct reports, project teams, the teams that carry out the work</a:t>
+            </a:r>
+          </a:p>
+          <a:p>
+            <a:r>
+              <a:t>Key question</a:t>
+            </a:r>
+          </a:p>
+          <a:p>
+            <a:r>
+              <a:t>Who must deliver specific activities for this outcome to be achieved?</a:t>
+            </a:r>
+          </a:p>
+          <a:p/>
+          <a:p>
+            <a:r>
+              <a:t>3. Crossline</a:t>
+            </a:r>
+          </a:p>
+          <a:p>
+            <a:r>
+              <a:t>Who</a:t>
+            </a:r>
+          </a:p>
+          <a:p>
+            <a:r>
+              <a:t>Those whose contributions are interdependent</a:t>
+            </a:r>
+          </a:p>
+          <a:p>
+            <a:r>
+              <a:t>What must be established</a:t>
+            </a:r>
+          </a:p>
+          <a:p>
+            <a:r>
+              <a:t>Expectations for handovers, coordination, shared responsibilities and delivery commitments.</a:t>
+            </a:r>
+          </a:p>
+          <a:p>
+            <a:r>
+              <a:t>Examples</a:t>
+            </a:r>
+          </a:p>
+          <a:p>
+            <a:r>
+              <a:t>Peer functions, shared service functions, suppliers, service partners, technology vendors</a:t>
+            </a:r>
+          </a:p>
+          <a:p>
+            <a:r>
+              <a:t>Key question</a:t>
+            </a:r>
+          </a:p>
+          <a:p>
+            <a:r>
+              <a:t>Whose contributions must connect with this one for the outcome to be delivered?</a:t>
+            </a:r>
+          </a:p>
+          <a:p/>
+          <a:p>
+            <a:r>
+              <a:t>Its output: A clear understanding of the accountability relationships in which performance expectations must be established.</a:t>
+            </a:r>
+          </a:p>
+          <a:p/>
+          <a:p>
+            <a:r>
+              <a:t>The Critical Distinction</a:t>
+            </a:r>
+          </a:p>
+          <a:p>
+            <a:r>
+              <a:t>Contribution Map: Customer Service requires IT to maintain a reliable case-management system to achieve its response-time target. This establishes a dependency.</a:t>
+            </a:r>
+          </a:p>
+          <a:p>
+            <a:r>
+              <a:t>Expectations Chain: The Customer Service Executive and IT Executive must establish expectations concerning system availability, incident response times, escalation arrangements and accountability for resolving failures. This establishes what must be agreed between the people responsible.</a:t>
+            </a:r>
+          </a:p>
+          <a:p/>
+          <a:p>
+            <a:r>
               <a:t>Outcomes depend on a web of contributors beyond the visible leaders. Map and value the wider contribution system.</a:t>
+            </a:r>
+          </a:p>
+          <a:p/>
+          <a:p>
+            <a:r>
+              <a:t>FACILITATOR GUIDANCE</a:t>
+            </a:r>
+          </a:p>
+          <a:p>
+            <a:r>
+              <a:t>Ask participants to pick one current Key Result and post in the chat one contributor from each direction: Upline, Downline and Crossline. Then ask: “Have you had an alignment dialogue with everyone in that chain? Or only with the person holding the KPI?” Most will realise they have had the conversation with one person and assumed the rest of the chain would follow. That assumption is where most execution gaps begin.</a:t>
             </a:r>
           </a:p>
         </p:txBody>
@@ -5001,31 +4859,45 @@
           <a:lstStyle/>
           <a:p>
             <a:r>
-              <a:rPr lang="en-US" dirty="0"/>
-              <a:t>1.4 — THE ALIGNMENT DIALOGUE (Testing whether the expectation is owned)
-With the Expectations Chain mapped, the leader conducts an Alignment Dialogue with the individuals responsible for delivering the OKR/KPI. This is a structured conversation designed to test whether the expectation has moved from instruction to commitment.
-</a:t>
-            </a:r>
-          </a:p>
-          <a:p>
-            <a:r>
-              <a:rPr lang="en-US" dirty="0"/>
+              <a:t>1.4 — THE ALIGNMENT DIALOGUE (Testing whether the expectation is owned)</a:t>
+            </a:r>
+          </a:p>
+          <a:p/>
+          <a:p/>
+          <a:p>
+            <a:r>
+              <a:t>With the Expectations Chain mapped, the leader conducts an Alignment Dialogue with the individuals responsible for delivering the OKR/KPI. This is a structured conversation designed to test whether the expectation has moved from instruction to commitment.</a:t>
+            </a:r>
+          </a:p>
+          <a:p/>
+          <a:p>
+            <a:r>
+              <a:t>The Alignment Dialogue tests two questions together: “What contribution will you deliver?” and “What must the organisation enable for you to deliver it?” The leader asks the individual to explain the target in their own words, describe the behaviours and evidence, identify ESRG constraints and dependencies, and confirm what they can commit to.</a:t>
+            </a:r>
+          </a:p>
+          <a:p>
+            <a:r>
+              <a:t>Where alignment is below the agreed threshold, the leader explores the reason, separating a clarity gap, a skill or commitment gap, and an ESRG or cross-functional constraint. The leader agrees a specific resolution owner and review date before recording the expectation as established.</a:t>
+            </a:r>
+          </a:p>
+          <a:p/>
+          <a:p>
+            <a:r>
               <a:t>The Alignment Dialogue uses a simple scale of 1–10. A score of 9 or 10 indicates genuine ownership of delivery. </a:t>
             </a:r>
           </a:p>
           <a:p>
             <a:r>
-              <a:rPr lang="en-US" dirty="0"/>
-              <a:t>Anything lower demands further deliberation through the Score → Evaluate → Resolve sequence.
-The power of the Alignment Dialogue lies in what the number reveals. A score of 6 is data: there is something unresolved between the expectation and the person’s readiness to own it. The leader’s job is to find it and resolve it before execution begins.</a:t>
-            </a:r>
-          </a:p>
-          <a:p>
-            <a:endParaRPr lang="en-US" dirty="0"/>
-          </a:p>
-          <a:p>
-            <a:endParaRPr dirty="0"/>
-          </a:p>
+              <a:t>Anything lower demands further deliberation through the Score → Evaluate → Resolve sequence.</a:t>
+            </a:r>
+          </a:p>
+          <a:p>
+            <a:r>
+              <a:t>The power of the Alignment Dialogue lies in what the number reveals. A score of 6 is data: there is something unresolved between the expectation and the person’s readiness to own it. The leader’s job is to find it and resolve it before execution begins.</a:t>
+            </a:r>
+          </a:p>
+          <a:p/>
+          <a:p/>
         </p:txBody>
       </p:sp>
       <p:sp>
@@ -5887,7 +5759,7 @@
                 <a:ea typeface="Calibri" pitchFamily="34" charset="-122"/>
                 <a:cs typeface="Calibri" pitchFamily="34" charset="-120"/>
               </a:rPr>
-              <a:t>Turning delivery goals into genuine ownership</a:t>
+              <a:t>Turning delivery goals into genuine ownership across the Human and Organisational Operating Systems</a:t>
             </a:r>
             <a:endParaRPr lang="en-US" sz="2400" dirty="0"/>
           </a:p>
@@ -6745,7 +6617,7 @@
                 <a:ea typeface="Calibri" pitchFamily="34" charset="-122"/>
                 <a:cs typeface="Calibri" pitchFamily="34" charset="-120"/>
               </a:rPr>
-              <a:t>Explain how establishing expectations builds ownership and mutual accountability.</a:t>
+              <a:t>Explain how expectation alignment affects commitment and execution.</a:t>
             </a:r>
             <a:endParaRPr lang="en-US" sz="2400" dirty="0"/>
           </a:p>
@@ -6840,7 +6712,7 @@
                 <a:ea typeface="Calibri" pitchFamily="34" charset="-122"/>
                 <a:cs typeface="Calibri" pitchFamily="34" charset="-120"/>
               </a:rPr>
-              <a:t>Recognise how engagement and accountability degrade when expectations are only communicated.</a:t>
+              <a:t>Diagnose the performance consequences of unclear human and ESRG expectations.</a:t>
             </a:r>
             <a:endParaRPr lang="en-US" sz="2400" dirty="0"/>
           </a:p>
@@ -8994,7 +8866,7 @@
                 <a:ea typeface="Calibri" pitchFamily="34" charset="-122"/>
                 <a:cs typeface="Calibri" pitchFamily="34" charset="-120"/>
               </a:rPr>
-              <a:t>Identify where each executive function tends to set expectations without securing ownership.</a:t>
+              <a:t>Identify leadership tendencies that weaken expectation alignment.</a:t>
             </a:r>
             <a:endParaRPr lang="en-US" sz="2400" dirty="0"/>
           </a:p>
@@ -9089,7 +8961,7 @@
                 <a:ea typeface="Calibri" pitchFamily="34" charset="-122"/>
                 <a:cs typeface="Calibri" pitchFamily="34" charset="-120"/>
               </a:rPr>
-              <a:t>Recognise the contributors and dependencies each executive role relies on to deliver an agreed result.</a:t>
+              <a:t>Locate ownership gaps across contribution relationships and enabling conditions.</a:t>
             </a:r>
             <a:endParaRPr lang="en-US" sz="2400" dirty="0"/>
           </a:p>
@@ -9682,7 +9554,7 @@
                 <a:ea typeface="Calibri" pitchFamily="34" charset="-122"/>
                 <a:cs typeface="Calibri" pitchFamily="34" charset="-120"/>
               </a:rPr>
-              <a:t>Apply a consistent leadership practice for establishing expectations across the organisation.</a:t>
+              <a:t>Coach individuals from partial alignment to genuine commitment.</a:t>
             </a:r>
             <a:endParaRPr lang="en-US" sz="2400" dirty="0"/>
           </a:p>
@@ -9777,505 +9649,9 @@
                 <a:ea typeface="Calibri" pitchFamily="34" charset="-122"/>
                 <a:cs typeface="Calibri" pitchFamily="34" charset="-120"/>
               </a:rPr>
-              <a:t>Coach individuals from partial alignment to genuine commitment.</a:t>
+              <a:t>Demonstrate an alignment dialogue covering commitments and ESRG dependencies.</a:t>
             </a:r>
             <a:endParaRPr lang="en-US" sz="2400" dirty="0"/>
-          </a:p>
-        </p:txBody>
-      </p:sp>
-    </p:spTree>
-  </p:cSld>
-  <p:clrMapOvr>
-    <a:masterClrMapping/>
-  </p:clrMapOvr>
-</p:sld>
-</file>
-
-<file path=ppt/slides/slide19.xml><?xml version="1.0" encoding="utf-8"?>
-<p:sld xmlns:a="http://schemas.openxmlformats.org/drawingml/2006/main" xmlns:r="http://schemas.openxmlformats.org/officeDocument/2006/relationships" xmlns:p="http://schemas.openxmlformats.org/presentationml/2006/main">
-  <p:cSld name="Slide 16">
-    <p:bg>
-      <p:bgPr>
-        <a:solidFill>
-          <a:srgbClr val="FFFFFF"/>
-        </a:solidFill>
-        <a:effectLst/>
-      </p:bgPr>
-    </p:bg>
-    <p:spTree>
-      <p:nvGrpSpPr>
-        <p:cNvPr id="1" name=""/>
-        <p:cNvGrpSpPr/>
-        <p:nvPr/>
-      </p:nvGrpSpPr>
-      <p:grpSpPr>
-        <a:xfrm>
-          <a:off x="0" y="0"/>
-          <a:ext cx="0" cy="0"/>
-          <a:chOff x="0" y="0"/>
-          <a:chExt cx="0" cy="0"/>
-        </a:xfrm>
-      </p:grpSpPr>
-      <p:sp>
-        <p:nvSpPr>
-          <p:cNvPr id="2" name="Text 0"/>
-          <p:cNvSpPr txBox="1"/>
-          <p:nvPr/>
-        </p:nvSpPr>
-        <p:spPr>
-          <a:xfrm>
-            <a:off x="548640" y="411480"/>
-            <a:ext cx="11064240" cy="868680"/>
-          </a:xfrm>
-          <a:prstGeom prst="rect">
-            <a:avLst/>
-          </a:prstGeom>
-          <a:noFill/>
-          <a:ln/>
-        </p:spPr>
-        <p:txBody>
-          <a:bodyPr wrap="square" lIns="0" tIns="0" rIns="0" bIns="0" rtlCol="0" anchor="ctr"/>
-          <a:lstStyle/>
-          <a:p>
-            <a:pPr marL="0" indent="0">
-              <a:buNone/>
-            </a:pPr>
-            <a:r>
-              <a:rPr lang="en-US" sz="3600" b="1" dirty="0">
-                <a:solidFill>
-                  <a:srgbClr val="1A5C2C"/>
-                </a:solidFill>
-                <a:latin typeface="Cambria" pitchFamily="34" charset="0"/>
-                <a:ea typeface="Cambria" pitchFamily="34" charset="-122"/>
-                <a:cs typeface="Cambria" pitchFamily="34" charset="-120"/>
-              </a:rPr>
-              <a:t>4.1 · The four-step Expectation Architecture</a:t>
-            </a:r>
-            <a:endParaRPr lang="en-US" sz="3600" dirty="0"/>
-          </a:p>
-        </p:txBody>
-      </p:sp>
-      <p:sp>
-        <p:nvSpPr>
-          <p:cNvPr id="3" name="Shape 1"/>
-          <p:cNvSpPr/>
-          <p:nvPr/>
-        </p:nvSpPr>
-        <p:spPr>
-          <a:xfrm>
-            <a:off x="548640" y="1800225"/>
-            <a:ext cx="640080" cy="640080"/>
-          </a:xfrm>
-          <a:prstGeom prst="ellipse">
-            <a:avLst/>
-          </a:prstGeom>
-          <a:solidFill>
-            <a:srgbClr val="1A5C2C"/>
-          </a:solidFill>
-          <a:ln w="12700">
-            <a:solidFill>
-              <a:srgbClr val="1A5C2C"/>
-            </a:solidFill>
-            <a:prstDash val="solid"/>
-          </a:ln>
-        </p:spPr>
-        <p:txBody>
-          <a:bodyPr/>
-          <a:lstStyle/>
-          <a:p>
-            <a:endParaRPr lang="en-ZA"/>
-          </a:p>
-        </p:txBody>
-      </p:sp>
-      <p:pic>
-        <p:nvPicPr>
-          <p:cNvPr id="4" name="Image 0" descr="preencoded.png"/>
-          <p:cNvPicPr>
-            <a:picLocks noChangeAspect="1"/>
-          </p:cNvPicPr>
-          <p:nvPr/>
-        </p:nvPicPr>
-        <p:blipFill>
-          <a:blip r:embed="rId3"/>
-          <a:stretch>
-            <a:fillRect/>
-          </a:stretch>
-        </p:blipFill>
-        <p:spPr>
-          <a:xfrm>
-            <a:off x="708660" y="1960245"/>
-            <a:ext cx="320040" cy="320040"/>
-          </a:xfrm>
-          <a:prstGeom prst="rect">
-            <a:avLst/>
-          </a:prstGeom>
-        </p:spPr>
-      </p:pic>
-      <p:sp>
-        <p:nvSpPr>
-          <p:cNvPr id="5" name="Text 2"/>
-          <p:cNvSpPr txBox="1"/>
-          <p:nvPr/>
-        </p:nvSpPr>
-        <p:spPr>
-          <a:xfrm>
-            <a:off x="1508760" y="1508760"/>
-            <a:ext cx="10131552" cy="1223010"/>
-          </a:xfrm>
-          <a:prstGeom prst="rect">
-            <a:avLst/>
-          </a:prstGeom>
-          <a:noFill/>
-          <a:ln/>
-        </p:spPr>
-        <p:txBody>
-          <a:bodyPr wrap="square" lIns="0" tIns="0" rIns="0" bIns="0" rtlCol="0" anchor="ctr"/>
-          <a:lstStyle/>
-          <a:p>
-            <a:pPr marL="0" indent="0">
-              <a:buNone/>
-            </a:pPr>
-            <a:r>
-              <a:rPr lang="en-US" sz="2600" b="1" dirty="0">
-                <a:solidFill>
-                  <a:srgbClr val="1A5C2C"/>
-                </a:solidFill>
-                <a:latin typeface="Cambria" pitchFamily="34" charset="0"/>
-                <a:ea typeface="Cambria" pitchFamily="34" charset="-122"/>
-                <a:cs typeface="Cambria" pitchFamily="34" charset="-120"/>
-              </a:rPr>
-              <a:t>1 · Start With the Future  </a:t>
-            </a:r>
-            <a:r>
-              <a:rPr lang="en-US" sz="2600" dirty="0">
-                <a:solidFill>
-                  <a:srgbClr val="1F2A22"/>
-                </a:solidFill>
-                <a:latin typeface="Calibri" pitchFamily="34" charset="0"/>
-                <a:ea typeface="Calibri" pitchFamily="34" charset="-122"/>
-                <a:cs typeface="Calibri" pitchFamily="34" charset="-120"/>
-              </a:rPr>
-              <a:t>why the expectation matters</a:t>
-            </a:r>
-            <a:endParaRPr lang="en-US" sz="2600" dirty="0"/>
-          </a:p>
-        </p:txBody>
-      </p:sp>
-      <p:sp>
-        <p:nvSpPr>
-          <p:cNvPr id="6" name="Shape 3"/>
-          <p:cNvSpPr/>
-          <p:nvPr/>
-        </p:nvSpPr>
-        <p:spPr>
-          <a:xfrm>
-            <a:off x="548640" y="3023235"/>
-            <a:ext cx="640080" cy="640080"/>
-          </a:xfrm>
-          <a:prstGeom prst="ellipse">
-            <a:avLst/>
-          </a:prstGeom>
-          <a:solidFill>
-            <a:srgbClr val="1A5C2C"/>
-          </a:solidFill>
-          <a:ln w="12700">
-            <a:solidFill>
-              <a:srgbClr val="1A5C2C"/>
-            </a:solidFill>
-            <a:prstDash val="solid"/>
-          </a:ln>
-        </p:spPr>
-        <p:txBody>
-          <a:bodyPr/>
-          <a:lstStyle/>
-          <a:p>
-            <a:endParaRPr lang="en-ZA"/>
-          </a:p>
-        </p:txBody>
-      </p:sp>
-      <p:pic>
-        <p:nvPicPr>
-          <p:cNvPr id="7" name="Image 1" descr="preencoded.png"/>
-          <p:cNvPicPr>
-            <a:picLocks noChangeAspect="1"/>
-          </p:cNvPicPr>
-          <p:nvPr/>
-        </p:nvPicPr>
-        <p:blipFill>
-          <a:blip r:embed="rId4"/>
-          <a:stretch>
-            <a:fillRect/>
-          </a:stretch>
-        </p:blipFill>
-        <p:spPr>
-          <a:xfrm>
-            <a:off x="708660" y="3183255"/>
-            <a:ext cx="320040" cy="320040"/>
-          </a:xfrm>
-          <a:prstGeom prst="rect">
-            <a:avLst/>
-          </a:prstGeom>
-        </p:spPr>
-      </p:pic>
-      <p:sp>
-        <p:nvSpPr>
-          <p:cNvPr id="8" name="Text 4"/>
-          <p:cNvSpPr txBox="1"/>
-          <p:nvPr/>
-        </p:nvSpPr>
-        <p:spPr>
-          <a:xfrm>
-            <a:off x="1508760" y="2731770"/>
-            <a:ext cx="10131552" cy="1223010"/>
-          </a:xfrm>
-          <a:prstGeom prst="rect">
-            <a:avLst/>
-          </a:prstGeom>
-          <a:noFill/>
-          <a:ln/>
-        </p:spPr>
-        <p:txBody>
-          <a:bodyPr wrap="square" lIns="0" tIns="0" rIns="0" bIns="0" rtlCol="0" anchor="ctr"/>
-          <a:lstStyle/>
-          <a:p>
-            <a:pPr marL="0" indent="0">
-              <a:buNone/>
-            </a:pPr>
-            <a:r>
-              <a:rPr lang="en-US" sz="2600" b="1" dirty="0">
-                <a:solidFill>
-                  <a:srgbClr val="1A5C2C"/>
-                </a:solidFill>
-                <a:latin typeface="Cambria" pitchFamily="34" charset="0"/>
-                <a:ea typeface="Cambria" pitchFamily="34" charset="-122"/>
-                <a:cs typeface="Cambria" pitchFamily="34" charset="-120"/>
-              </a:rPr>
-              <a:t>2 · Clarify the Delivery Expectation  </a:t>
-            </a:r>
-            <a:r>
-              <a:rPr lang="en-US" sz="2600" dirty="0">
-                <a:solidFill>
-                  <a:srgbClr val="1F2A22"/>
-                </a:solidFill>
-                <a:latin typeface="Calibri" pitchFamily="34" charset="0"/>
-                <a:ea typeface="Calibri" pitchFamily="34" charset="-122"/>
-                <a:cs typeface="Calibri" pitchFamily="34" charset="-120"/>
-              </a:rPr>
-              <a:t>in outcome terms</a:t>
-            </a:r>
-            <a:endParaRPr lang="en-US" sz="2600" dirty="0"/>
-          </a:p>
-        </p:txBody>
-      </p:sp>
-      <p:sp>
-        <p:nvSpPr>
-          <p:cNvPr id="9" name="Shape 5"/>
-          <p:cNvSpPr/>
-          <p:nvPr/>
-        </p:nvSpPr>
-        <p:spPr>
-          <a:xfrm>
-            <a:off x="548640" y="4246245"/>
-            <a:ext cx="640080" cy="640080"/>
-          </a:xfrm>
-          <a:prstGeom prst="ellipse">
-            <a:avLst/>
-          </a:prstGeom>
-          <a:solidFill>
-            <a:srgbClr val="1A5C2C"/>
-          </a:solidFill>
-          <a:ln w="12700">
-            <a:solidFill>
-              <a:srgbClr val="1A5C2C"/>
-            </a:solidFill>
-            <a:prstDash val="solid"/>
-          </a:ln>
-        </p:spPr>
-        <p:txBody>
-          <a:bodyPr/>
-          <a:lstStyle/>
-          <a:p>
-            <a:endParaRPr lang="en-ZA"/>
-          </a:p>
-        </p:txBody>
-      </p:sp>
-      <p:pic>
-        <p:nvPicPr>
-          <p:cNvPr id="10" name="Image 2" descr="preencoded.png"/>
-          <p:cNvPicPr>
-            <a:picLocks noChangeAspect="1"/>
-          </p:cNvPicPr>
-          <p:nvPr/>
-        </p:nvPicPr>
-        <p:blipFill>
-          <a:blip r:embed="rId5"/>
-          <a:stretch>
-            <a:fillRect/>
-          </a:stretch>
-        </p:blipFill>
-        <p:spPr>
-          <a:xfrm>
-            <a:off x="708660" y="4406265"/>
-            <a:ext cx="320040" cy="320040"/>
-          </a:xfrm>
-          <a:prstGeom prst="rect">
-            <a:avLst/>
-          </a:prstGeom>
-        </p:spPr>
-      </p:pic>
-      <p:sp>
-        <p:nvSpPr>
-          <p:cNvPr id="11" name="Text 6"/>
-          <p:cNvSpPr txBox="1"/>
-          <p:nvPr/>
-        </p:nvSpPr>
-        <p:spPr>
-          <a:xfrm>
-            <a:off x="1508760" y="3954780"/>
-            <a:ext cx="10131552" cy="1223010"/>
-          </a:xfrm>
-          <a:prstGeom prst="rect">
-            <a:avLst/>
-          </a:prstGeom>
-          <a:noFill/>
-          <a:ln/>
-        </p:spPr>
-        <p:txBody>
-          <a:bodyPr wrap="square" lIns="0" tIns="0" rIns="0" bIns="0" rtlCol="0" anchor="ctr"/>
-          <a:lstStyle/>
-          <a:p>
-            <a:pPr marL="0" indent="0">
-              <a:buNone/>
-            </a:pPr>
-            <a:r>
-              <a:rPr lang="en-US" sz="2600" b="1" dirty="0">
-                <a:solidFill>
-                  <a:srgbClr val="1A5C2C"/>
-                </a:solidFill>
-                <a:latin typeface="Cambria" pitchFamily="34" charset="0"/>
-                <a:ea typeface="Cambria" pitchFamily="34" charset="-122"/>
-                <a:cs typeface="Cambria" pitchFamily="34" charset="-120"/>
-              </a:rPr>
-              <a:t>3 · Identify the Expectations Chain  </a:t>
-            </a:r>
-            <a:r>
-              <a:rPr lang="en-US" sz="2600" dirty="0">
-                <a:solidFill>
-                  <a:srgbClr val="1F2A22"/>
-                </a:solidFill>
-                <a:latin typeface="Calibri" pitchFamily="34" charset="0"/>
-                <a:ea typeface="Calibri" pitchFamily="34" charset="-122"/>
-                <a:cs typeface="Calibri" pitchFamily="34" charset="-120"/>
-              </a:rPr>
-              <a:t>who else must contribute</a:t>
-            </a:r>
-            <a:endParaRPr lang="en-US" sz="2600" dirty="0"/>
-          </a:p>
-        </p:txBody>
-      </p:sp>
-      <p:sp>
-        <p:nvSpPr>
-          <p:cNvPr id="12" name="Shape 7"/>
-          <p:cNvSpPr/>
-          <p:nvPr/>
-        </p:nvSpPr>
-        <p:spPr>
-          <a:xfrm>
-            <a:off x="548640" y="5469255"/>
-            <a:ext cx="640080" cy="640080"/>
-          </a:xfrm>
-          <a:prstGeom prst="ellipse">
-            <a:avLst/>
-          </a:prstGeom>
-          <a:solidFill>
-            <a:srgbClr val="C6A24C"/>
-          </a:solidFill>
-          <a:ln w="12700">
-            <a:solidFill>
-              <a:srgbClr val="C6A24C"/>
-            </a:solidFill>
-            <a:prstDash val="solid"/>
-          </a:ln>
-        </p:spPr>
-        <p:txBody>
-          <a:bodyPr/>
-          <a:lstStyle/>
-          <a:p>
-            <a:endParaRPr lang="en-ZA"/>
-          </a:p>
-        </p:txBody>
-      </p:sp>
-      <p:pic>
-        <p:nvPicPr>
-          <p:cNvPr id="13" name="Image 3" descr="preencoded.png"/>
-          <p:cNvPicPr>
-            <a:picLocks noChangeAspect="1"/>
-          </p:cNvPicPr>
-          <p:nvPr/>
-        </p:nvPicPr>
-        <p:blipFill>
-          <a:blip r:embed="rId6"/>
-          <a:stretch>
-            <a:fillRect/>
-          </a:stretch>
-        </p:blipFill>
-        <p:spPr>
-          <a:xfrm>
-            <a:off x="708660" y="5629275"/>
-            <a:ext cx="320040" cy="320040"/>
-          </a:xfrm>
-          <a:prstGeom prst="rect">
-            <a:avLst/>
-          </a:prstGeom>
-        </p:spPr>
-      </p:pic>
-      <p:sp>
-        <p:nvSpPr>
-          <p:cNvPr id="14" name="Text 8"/>
-          <p:cNvSpPr txBox="1"/>
-          <p:nvPr/>
-        </p:nvSpPr>
-        <p:spPr>
-          <a:xfrm>
-            <a:off x="1508760" y="5177790"/>
-            <a:ext cx="10131552" cy="1223010"/>
-          </a:xfrm>
-          <a:prstGeom prst="rect">
-            <a:avLst/>
-          </a:prstGeom>
-          <a:noFill/>
-          <a:ln/>
-        </p:spPr>
-        <p:txBody>
-          <a:bodyPr wrap="square" lIns="0" tIns="0" rIns="0" bIns="0" rtlCol="0" anchor="ctr"/>
-          <a:lstStyle/>
-          <a:p>
-            <a:pPr marL="0" indent="0">
-              <a:buNone/>
-            </a:pPr>
-            <a:r>
-              <a:rPr lang="en-US" sz="2600" b="1" dirty="0">
-                <a:solidFill>
-                  <a:srgbClr val="1A5C2C"/>
-                </a:solidFill>
-                <a:latin typeface="Cambria" pitchFamily="34" charset="0"/>
-                <a:ea typeface="Cambria" pitchFamily="34" charset="-122"/>
-                <a:cs typeface="Cambria" pitchFamily="34" charset="-120"/>
-              </a:rPr>
-              <a:t>4 · Confirm Ownership  </a:t>
-            </a:r>
-            <a:r>
-              <a:rPr lang="en-US" sz="2600" dirty="0">
-                <a:solidFill>
-                  <a:srgbClr val="1F2A22"/>
-                </a:solidFill>
-                <a:latin typeface="Calibri" pitchFamily="34" charset="0"/>
-                <a:ea typeface="Calibri" pitchFamily="34" charset="-122"/>
-                <a:cs typeface="Calibri" pitchFamily="34" charset="-120"/>
-              </a:rPr>
-              <a:t>ask the Alignment Question</a:t>
-            </a:r>
-            <a:endParaRPr lang="en-US" sz="2600" dirty="0"/>
           </a:p>
         </p:txBody>
       </p:sp>
@@ -10440,7 +9816,7 @@
                 <a:ea typeface="Calibri" pitchFamily="34" charset="-122"/>
                 <a:cs typeface="Calibri" pitchFamily="34" charset="-120"/>
               </a:rPr>
-              <a:t>Articulate performance expectations that are clear, strategically relevant and consistent with enterprise outcomes.</a:t>
+              <a:t>Establish performance expectations linked to enterprise outcomes and mapped contributions.</a:t>
             </a:r>
             <a:endParaRPr lang="en-US" sz="2400" dirty="0"/>
           </a:p>
@@ -10535,7 +9911,7 @@
                 <a:ea typeface="Calibri" pitchFamily="34" charset="-122"/>
                 <a:cs typeface="Calibri" pitchFamily="34" charset="-120"/>
               </a:rPr>
-              <a:t>Evaluate the readiness of individuals and teams to fulfil their strategic responsibilities.</a:t>
+              <a:t>Test clarity, capability and commitment across the Human and Organisational Operating Systems.</a:t>
             </a:r>
             <a:endParaRPr lang="en-US" sz="2400" dirty="0"/>
           </a:p>
@@ -10630,7 +10006,7 @@
                 <a:ea typeface="Calibri" pitchFamily="34" charset="-122"/>
                 <a:cs typeface="Calibri" pitchFamily="34" charset="-120"/>
               </a:rPr>
-              <a:t>Recognise the contribution relationships and dependencies that influence organisational performance.</a:t>
+              <a:t>Identify cross-functional dependencies and agree accountability for enabling conditions.</a:t>
             </a:r>
             <a:endParaRPr lang="en-US" sz="2400" dirty="0"/>
           </a:p>
@@ -10797,7 +10173,7 @@
                 <a:ea typeface="Cambria" pitchFamily="34" charset="-122"/>
                 <a:cs typeface="Cambria" pitchFamily="34" charset="-120"/>
               </a:rPr>
-              <a:t>4.2 · Practising the Alignment Dialogue</a:t>
+              <a:t>4.1 · Practising the Alignment Dialogue</a:t>
             </a:r>
             <a:endParaRPr lang="en-US" sz="3600" dirty="0"/>
           </a:p>
@@ -11299,7 +10675,7 @@
                 <a:ea typeface="Cambria" pitchFamily="34" charset="-122"/>
                 <a:cs typeface="Cambria" pitchFamily="34" charset="-120"/>
               </a:rPr>
-              <a:t>Section 4 Reflections</a:t>
+              <a:t>Section 4 · Portfolio work</a:t>
             </a:r>
             <a:endParaRPr lang="en-US" sz="3600" dirty="0"/>
           </a:p>
@@ -11307,22 +10683,22 @@
       </p:sp>
       <p:pic>
         <p:nvPicPr>
-          <p:cNvPr id="3" name="Reflection 4.1" descr="✎ REFLECTION — WHICH STEP DO YOU MOST OFTEN SKIP?. Of the four steps, which one do you most often move through too quickly? What would change if you gave it more time?"/>
+          <p:cNvPr id="7" name="Reflection 4.2" descr="PORTFOLIO WORK · HOW TO COMPLETE THE ALIGNMENT DIALOGUE."/>
           <p:cNvPicPr>
             <a:picLocks noChangeAspect="1"/>
           </p:cNvPicPr>
           <p:nvPr/>
         </p:nvPicPr>
         <p:blipFill>
-          <a:blip r:embed="rId3"/>
+          <a:blip r:embed="rId5"/>
           <a:stretch>
             <a:fillRect/>
           </a:stretch>
         </p:blipFill>
         <p:spPr>
           <a:xfrm>
-            <a:off x="1691640" y="1572768"/>
-            <a:ext cx="9921240" cy="1051822"/>
+            <a:off x="1691640" y="2917198"/>
+            <a:ext cx="9921240" cy="2530058"/>
           </a:xfrm>
           <a:prstGeom prst="rect">
             <a:avLst/>
@@ -11331,13 +10707,13 @@
       </p:pic>
       <p:sp>
         <p:nvSpPr>
-          <p:cNvPr id="4" name="Part 4.1"/>
+          <p:cNvPr id="6" name="Part 4.2"/>
           <p:cNvSpPr/>
           <p:nvPr/>
         </p:nvSpPr>
         <p:spPr>
           <a:xfrm>
-            <a:off x="548640" y="1664339"/>
+            <a:off x="548640" y="3214378"/>
             <a:ext cx="868680" cy="868680"/>
           </a:xfrm>
           <a:prstGeom prst="ellipse">
@@ -11380,85 +10756,6 @@
                 <a:latin typeface="Calibri"/>
               </a:rPr>
               <a:t>4.1</a:t>
-            </a:r>
-          </a:p>
-        </p:txBody>
-      </p:sp>
-      <p:pic>
-        <p:nvPicPr>
-          <p:cNvPr id="7" name="Reflection 4.2" descr="PORTFOLIO WORK · HOW TO COMPLETE THE ALIGNMENT DIALOGUE."/>
-          <p:cNvPicPr>
-            <a:picLocks noChangeAspect="1"/>
-          </p:cNvPicPr>
-          <p:nvPr/>
-        </p:nvPicPr>
-        <p:blipFill>
-          <a:blip r:embed="rId5"/>
-          <a:stretch>
-            <a:fillRect/>
-          </a:stretch>
-        </p:blipFill>
-        <p:spPr>
-          <a:xfrm>
-            <a:off x="1691640" y="2917198"/>
-            <a:ext cx="9921240" cy="2530058"/>
-          </a:xfrm>
-          <a:prstGeom prst="rect">
-            <a:avLst/>
-          </a:prstGeom>
-        </p:spPr>
-      </p:pic>
-      <p:sp>
-        <p:nvSpPr>
-          <p:cNvPr id="6" name="Part 4.2"/>
-          <p:cNvSpPr/>
-          <p:nvPr/>
-        </p:nvSpPr>
-        <p:spPr>
-          <a:xfrm>
-            <a:off x="548640" y="3214378"/>
-            <a:ext cx="868680" cy="868680"/>
-          </a:xfrm>
-          <a:prstGeom prst="ellipse">
-            <a:avLst/>
-          </a:prstGeom>
-          <a:solidFill>
-            <a:srgbClr val="C6A24C"/>
-          </a:solidFill>
-          <a:ln>
-            <a:solidFill>
-              <a:srgbClr val="C6A24C"/>
-            </a:solidFill>
-          </a:ln>
-          <a:effectLst/>
-        </p:spPr>
-        <p:style>
-          <a:lnRef idx="1">
-            <a:schemeClr val="accent1"/>
-          </a:lnRef>
-          <a:fillRef idx="3">
-            <a:schemeClr val="accent1"/>
-          </a:fillRef>
-          <a:effectRef idx="2">
-            <a:schemeClr val="accent1"/>
-          </a:effectRef>
-          <a:fontRef idx="minor">
-            <a:schemeClr val="lt1"/>
-          </a:fontRef>
-        </p:style>
-        <p:txBody>
-          <a:bodyPr wrap="none" lIns="0" tIns="0" rIns="0" bIns="0" rtlCol="0" anchor="ctr"/>
-          <a:lstStyle/>
-          <a:p>
-            <a:pPr algn="ctr"/>
-            <a:r>
-              <a:rPr sz="2400" b="1">
-                <a:solidFill>
-                  <a:srgbClr val="FFFFFF"/>
-                </a:solidFill>
-                <a:latin typeface="Calibri"/>
-              </a:rPr>
-              <a:t>4.2</a:t>
             </a:r>
           </a:p>
         </p:txBody>
@@ -11780,7 +11077,7 @@
                 <a:ea typeface="Calibri" pitchFamily="34" charset="-122"/>
                 <a:cs typeface="Calibri" pitchFamily="34" charset="-120"/>
               </a:rPr>
-              <a:t>Establish delivery expectations that secure personal ownership of agreed results.</a:t>
+              <a:t>Establish expectations for the contributions mapped in the Capstone.</a:t>
             </a:r>
             <a:endParaRPr lang="en-US" sz="2400" dirty="0"/>
           </a:p>
@@ -11875,7 +11172,7 @@
                 <a:ea typeface="Calibri" pitchFamily="34" charset="-122"/>
                 <a:cs typeface="Calibri" pitchFamily="34" charset="-120"/>
               </a:rPr>
-              <a:t>Confirm the contributors and commitments that make mutual accountability visible.</a:t>
+              <a:t>Record agreed commitments, ESRG conditions and alignment actions in the Capstone Blueprint.</a:t>
             </a:r>
             <a:endParaRPr lang="en-US" sz="2400" dirty="0"/>
           </a:p>
@@ -12159,7 +11456,7 @@
                 <a:ea typeface="Calibri" pitchFamily="34" charset="-122"/>
                 <a:cs typeface="Calibri" pitchFamily="34" charset="-120"/>
               </a:rPr>
-              <a:t>what, by when, to what standard</a:t>
+              <a:t>  for the people and for the organisation</a:t>
             </a:r>
             <a:endParaRPr lang="en-US" sz="2600" dirty="0"/>
           </a:p>
@@ -12265,7 +11562,7 @@
                 <a:ea typeface="Calibri" pitchFamily="34" charset="-122"/>
                 <a:cs typeface="Calibri" pitchFamily="34" charset="-120"/>
               </a:rPr>
-              <a:t>Upline, Downline and External</a:t>
+              <a:t>  Upline, Downline and Crossline</a:t>
             </a:r>
             <a:endParaRPr lang="en-US" sz="2600" dirty="0"/>
           </a:p>
@@ -13785,7 +13082,7 @@
                 <a:ea typeface="Calibri" pitchFamily="34" charset="-122"/>
                 <a:cs typeface="Calibri" pitchFamily="34" charset="-120"/>
               </a:rPr>
-              <a:t>Understand the distinction between setting vs establishing expectations</a:t>
+              <a:t>Distinguish setting expectations from establishing shared ownership.</a:t>
             </a:r>
             <a:endParaRPr lang="en-US" sz="2400" dirty="0"/>
           </a:p>
@@ -13880,7 +13177,7 @@
                 <a:ea typeface="Calibri" pitchFamily="34" charset="-122"/>
                 <a:cs typeface="Calibri" pitchFamily="34" charset="-120"/>
               </a:rPr>
-              <a:t>Design clarity, capability and commitment to establish expectations.</a:t>
+              <a:t>Identify human commitments and organisational conditions that require agreement.</a:t>
             </a:r>
             <a:endParaRPr lang="en-US" sz="2400" dirty="0"/>
           </a:p>
@@ -14698,7 +13995,7 @@
                 <a:ea typeface="Calibri" pitchFamily="34" charset="-122"/>
                 <a:cs typeface="Calibri" pitchFamily="34" charset="-120"/>
               </a:rPr>
-              <a:t>The individual understands exactly what success looks like.</a:t>
+              <a:t>Everyone understands what is expected and why it matters.</a:t>
             </a:r>
             <a:endParaRPr lang="en-US" sz="2400" dirty="0"/>
           </a:p>
@@ -14866,7 +14163,7 @@
                 <a:ea typeface="Calibri" pitchFamily="34" charset="-122"/>
                 <a:cs typeface="Calibri" pitchFamily="34" charset="-120"/>
               </a:rPr>
-              <a:t>The system can realistically support delivery.</a:t>
+              <a:t>The people and the organisation can realistically deliver.</a:t>
             </a:r>
             <a:endParaRPr lang="en-US" sz="2400" dirty="0"/>
           </a:p>
@@ -15034,7 +14331,7 @@
                 <a:ea typeface="Calibri" pitchFamily="34" charset="-122"/>
                 <a:cs typeface="Calibri" pitchFamily="34" charset="-120"/>
               </a:rPr>
-              <a:t>The person consciously accepts ownership of the outcome.</a:t>
+              <a:t>Those responsible consciously accept delivering and enabling.</a:t>
             </a:r>
             <a:endParaRPr lang="en-US" sz="2400" dirty="0"/>
           </a:p>
@@ -15644,7 +14941,7 @@
                 <a:ea typeface="Cambria" pitchFamily="34" charset="-122"/>
                 <a:cs typeface="Cambria" pitchFamily="34" charset="-120"/>
               </a:rPr>
-              <a:t>External</a:t>
+              <a:t>Crossline</a:t>
             </a:r>
             <a:endParaRPr lang="en-US" sz="2600" dirty="0"/>
           </a:p>
@@ -15683,7 +14980,7 @@
                 <a:ea typeface="Calibri" pitchFamily="34" charset="-122"/>
                 <a:cs typeface="Calibri" pitchFamily="34" charset="-120"/>
               </a:rPr>
-              <a:t>Which external actors influence delivery?</a:t>
+              <a:t>Whose contributions must connect with this one?</a:t>
             </a:r>
             <a:endParaRPr lang="en-US" sz="2400" dirty="0"/>
           </a:p>

</xml_diff>